<commit_message>
updated report and presentation
</commit_message>
<xml_diff>
--- a/presentation.pptx
+++ b/presentation.pptx
@@ -16,6 +16,7 @@
     <p:sldId id="264" r:id="rId10"/>
     <p:sldId id="265" r:id="rId11"/>
     <p:sldId id="266" r:id="rId12"/>
+    <p:sldId id="271" r:id="rId22"/>
     <p:sldId id="267" r:id="rId13"/>
     <p:sldId id="268" r:id="rId14"/>
     <p:sldId id="269" r:id="rId15"/>
@@ -2140,6 +2141,10 @@
           </a:solidFill>
           <a:ln/>
         </p:spPr>
+        <p:txBody>
+          <a:bodyPr/>
+          <a:p/>
+        </p:txBody>
       </p:sp>
       <p:sp>
         <p:nvSpPr>
@@ -2221,14 +2226,14 @@
       </p:sp>
       <p:sp>
         <p:nvSpPr>
-          <p:cNvPr id="5" name="Text 3"/>
-          <p:cNvSpPr/>
-          <p:nvPr/>
-        </p:nvSpPr>
-        <p:spPr>
-          <a:xfrm>
-            <a:off x="841248" y="4114800"/>
-            <a:ext cx="10058400" cy="365760"/>
+          <p:cNvPr id="6" name="Text 4"/>
+          <p:cNvSpPr/>
+          <p:nvPr/>
+        </p:nvSpPr>
+        <p:spPr>
+          <a:xfrm>
+            <a:off x="841248" y="5943600"/>
+            <a:ext cx="7315200" cy="365760"/>
           </a:xfrm>
           <a:prstGeom prst="rect">
             <a:avLst/>
@@ -2244,70 +2249,62 @@
               <a:buNone/>
             </a:pPr>
             <a:r>
-              <a:rPr lang="en-US" sz="1400" dirty="0">
-                <a:solidFill>
-                  <a:srgbClr val="9FB6C2"/>
+              <a:rPr lang="en-US" sz="1300" i="1" dirty="0">
+                <a:solidFill>
+                  <a:srgbClr val="7E94A0"/>
                 </a:solidFill>
                 <a:latin typeface="Calibri" pitchFamily="34" charset="0"/>
                 <a:ea typeface="Calibri" pitchFamily="34" charset="-122"/>
                 <a:cs typeface="Calibri" pitchFamily="34" charset="-120"/>
               </a:rPr>
-              <a:t>Train / validate on Fake-or-Real (FoR)   </a:t>
-            </a:r>
-            <a:pPr indent="0" marL="0">
-              <a:buNone/>
-            </a:pPr>
-            <a:r>
-              <a:rPr lang="en-US" sz="1400" b="1" dirty="0">
-                <a:solidFill>
-                  <a:srgbClr val="0E9594"/>
-                </a:solidFill>
-                <a:latin typeface="Calibri" pitchFamily="34" charset="0"/>
-                <a:ea typeface="Calibri" pitchFamily="34" charset="-122"/>
-                <a:cs typeface="Calibri" pitchFamily="34" charset="-120"/>
-              </a:rPr>
-              <a:t>·   Test on In-the-Wild (ITW)</a:t>
-            </a:r>
-            <a:endParaRPr lang="en-US" sz="1400" dirty="0"/>
-          </a:p>
-        </p:txBody>
-      </p:sp>
-      <p:sp>
-        <p:nvSpPr>
-          <p:cNvPr id="6" name="Text 4"/>
-          <p:cNvSpPr/>
-          <p:nvPr/>
-        </p:nvSpPr>
-        <p:spPr>
-          <a:xfrm>
-            <a:off x="841248" y="5943600"/>
-            <a:ext cx="7315200" cy="365760"/>
-          </a:xfrm>
-          <a:prstGeom prst="rect">
-            <a:avLst/>
-          </a:prstGeom>
-          <a:noFill/>
-          <a:ln/>
-        </p:spPr>
-        <p:txBody>
-          <a:bodyPr wrap="square" lIns="0" tIns="0" rIns="0" bIns="0" rtlCol="0" anchor="ctr"/>
-          <a:lstStyle/>
-          <a:p>
-            <a:pPr indent="0" marL="0">
-              <a:buNone/>
-            </a:pPr>
-            <a:r>
-              <a:rPr lang="en-US" sz="1300" i="1" dirty="0">
+              <a:t>Deep Learning course project</a:t>
+            </a:r>
+            <a:endParaRPr lang="en-US" sz="1300" dirty="0"/>
+          </a:p>
+        </p:txBody>
+      </p:sp>
+      <p:sp>
+        <p:nvSpPr>
+          <p:cNvPr id="7" name="TextBox 6"/>
+          <p:cNvSpPr txBox="1"/>
+          <p:nvPr/>
+        </p:nvSpPr>
+        <p:spPr>
+          <a:xfrm>
+            <a:off x="841248" y="6320000"/>
+            <a:ext cx="10058400" cy="500000"/>
+          </a:xfrm>
+          <a:prstGeom prst="rect">
+            <a:avLst/>
+          </a:prstGeom>
+          <a:noFill/>
+        </p:spPr>
+        <p:txBody>
+          <a:bodyPr wrap="none">
+            <a:spAutoFit/>
+          </a:bodyPr>
+          <a:lstStyle/>
+          <a:p>
+            <a:pPr algn="l"/>
+            <a:r>
+              <a:rPr sz="1100" b="0">
                 <a:solidFill>
                   <a:srgbClr val="7E94A0"/>
                 </a:solidFill>
-                <a:latin typeface="Calibri" pitchFamily="34" charset="0"/>
-                <a:ea typeface="Calibri" pitchFamily="34" charset="-122"/>
-                <a:cs typeface="Calibri" pitchFamily="34" charset="-120"/>
-              </a:rPr>
-              <a:t>Deep Learning course project</a:t>
-            </a:r>
-            <a:endParaRPr lang="en-US" sz="1300" dirty="0"/>
+              </a:rPr>
+              <a:t>George Nazos  MTN2519     |     Konstantinos Kaimakis  MTN2508</a:t>
+            </a:r>
+          </a:p>
+          <a:p>
+            <a:pPr algn="l"/>
+            <a:r>
+              <a:rPr sz="1000" b="0">
+                <a:solidFill>
+                  <a:srgbClr val="7E94A0"/>
+                </a:solidFill>
+              </a:rPr>
+              <a:t>MSc Artificial Intelligence  ·  NSCR Demokritos &amp; UNIPI</a:t>
+            </a:r>
           </a:p>
         </p:txBody>
       </p:sp>
@@ -2362,6 +2359,10 @@
           </a:solidFill>
           <a:ln/>
         </p:spPr>
+        <p:txBody>
+          <a:bodyPr/>
+          <a:p/>
+        </p:txBody>
       </p:sp>
       <p:sp>
         <p:nvSpPr>
@@ -2441,98 +2442,6 @@
           </a:p>
         </p:txBody>
       </p:sp>
-      <p:pic>
-        <p:nvPicPr>
-          <p:cNvPr id="5" name="Image 0" descr="/sessions/modest-trusting-fermi/mnt/outputs/slide_assets/probe_umap_20260620_170514.png">    </p:cNvPr>
-          <p:cNvPicPr>
-            <a:picLocks noChangeAspect="1"/>
-          </p:cNvPicPr>
-          <p:nvPr/>
-        </p:nvPicPr>
-        <p:blipFill>
-          <a:blip r:embed="rId1"/>
-          <a:srcRect l="0" r="0" t="0" b="0"/>
-          <a:stretch/>
-        </p:blipFill>
-        <p:spPr>
-          <a:xfrm>
-            <a:off x="1005840" y="1600200"/>
-            <a:ext cx="2743200" cy="2240280"/>
-          </a:xfrm>
-          <a:prstGeom prst="rect">
-            <a:avLst/>
-          </a:prstGeom>
-        </p:spPr>
-      </p:pic>
-      <p:pic>
-        <p:nvPicPr>
-          <p:cNvPr id="6" name="Image 1" descr="/sessions/modest-trusting-fermi/mnt/outputs/slide_assets/probe_scorehist_20260620_170514.png">    </p:cNvPr>
-          <p:cNvPicPr>
-            <a:picLocks noChangeAspect="1"/>
-          </p:cNvPicPr>
-          <p:nvPr/>
-        </p:nvPicPr>
-        <p:blipFill>
-          <a:blip r:embed="rId2"/>
-          <a:srcRect l="0" r="0" t="0" b="0"/>
-          <a:stretch/>
-        </p:blipFill>
-        <p:spPr>
-          <a:xfrm>
-            <a:off x="4023360" y="1920240"/>
-            <a:ext cx="3840480" cy="1554480"/>
-          </a:xfrm>
-          <a:prstGeom prst="rect">
-            <a:avLst/>
-          </a:prstGeom>
-        </p:spPr>
-      </p:pic>
-      <p:pic>
-        <p:nvPicPr>
-          <p:cNvPr id="7" name="Image 2" descr="/sessions/modest-trusting-fermi/mnt/outputs/slide_assets/umap_20260620_160154.png">    </p:cNvPr>
-          <p:cNvPicPr>
-            <a:picLocks noChangeAspect="1"/>
-          </p:cNvPicPr>
-          <p:nvPr/>
-        </p:nvPicPr>
-        <p:blipFill>
-          <a:blip r:embed="rId3"/>
-          <a:srcRect l="0" r="0" t="0" b="0"/>
-          <a:stretch/>
-        </p:blipFill>
-        <p:spPr>
-          <a:xfrm>
-            <a:off x="1005840" y="3977640"/>
-            <a:ext cx="2743200" cy="2240280"/>
-          </a:xfrm>
-          <a:prstGeom prst="rect">
-            <a:avLst/>
-          </a:prstGeom>
-        </p:spPr>
-      </p:pic>
-      <p:pic>
-        <p:nvPicPr>
-          <p:cNvPr id="8" name="Image 3" descr="/sessions/modest-trusting-fermi/mnt/outputs/slide_assets/scorehist_20260620_160154.png">    </p:cNvPr>
-          <p:cNvPicPr>
-            <a:picLocks noChangeAspect="1"/>
-          </p:cNvPicPr>
-          <p:nvPr/>
-        </p:nvPicPr>
-        <p:blipFill>
-          <a:blip r:embed="rId4"/>
-          <a:srcRect l="0" r="0" t="0" b="0"/>
-          <a:stretch/>
-        </p:blipFill>
-        <p:spPr>
-          <a:xfrm>
-            <a:off x="4023360" y="4297680"/>
-            <a:ext cx="3840480" cy="1554480"/>
-          </a:xfrm>
-          <a:prstGeom prst="rect">
-            <a:avLst/>
-          </a:prstGeom>
-        </p:spPr>
-      </p:pic>
       <p:sp>
         <p:nvSpPr>
           <p:cNvPr id="9" name="Text 3"/>
@@ -2771,6 +2680,102 @@
           </a:p>
         </p:txBody>
       </p:sp>
+      <p:pic>
+        <p:nvPicPr>
+          <p:cNvPr id="17" name="Picture 16" descr="image.png"/>
+          <p:cNvPicPr>
+            <a:picLocks noChangeAspect="1"/>
+          </p:cNvPicPr>
+          <p:nvPr/>
+        </p:nvPicPr>
+        <p:blipFill>
+          <a:blip r:embed="rId7"/>
+          <a:stretch>
+            <a:fillRect/>
+          </a:stretch>
+        </p:blipFill>
+        <p:spPr>
+          <a:xfrm>
+            <a:off x="1005840" y="1600200"/>
+            <a:ext cx="2743200" cy="2240280"/>
+          </a:xfrm>
+          <a:prstGeom prst="rect">
+            <a:avLst/>
+          </a:prstGeom>
+        </p:spPr>
+      </p:pic>
+      <p:pic>
+        <p:nvPicPr>
+          <p:cNvPr id="18" name="Picture 17" descr="image.png"/>
+          <p:cNvPicPr>
+            <a:picLocks noChangeAspect="1"/>
+          </p:cNvPicPr>
+          <p:nvPr/>
+        </p:nvPicPr>
+        <p:blipFill>
+          <a:blip r:embed="rId3"/>
+          <a:stretch>
+            <a:fillRect/>
+          </a:stretch>
+        </p:blipFill>
+        <p:spPr>
+          <a:xfrm>
+            <a:off x="4023360" y="1920240"/>
+            <a:ext cx="3840480" cy="1554480"/>
+          </a:xfrm>
+          <a:prstGeom prst="rect">
+            <a:avLst/>
+          </a:prstGeom>
+        </p:spPr>
+      </p:pic>
+      <p:pic>
+        <p:nvPicPr>
+          <p:cNvPr id="19" name="Picture 18" descr="image.png"/>
+          <p:cNvPicPr>
+            <a:picLocks noChangeAspect="1"/>
+          </p:cNvPicPr>
+          <p:nvPr/>
+        </p:nvPicPr>
+        <p:blipFill>
+          <a:blip r:embed="rId8"/>
+          <a:stretch>
+            <a:fillRect/>
+          </a:stretch>
+        </p:blipFill>
+        <p:spPr>
+          <a:xfrm>
+            <a:off x="1005840" y="3977640"/>
+            <a:ext cx="2743200" cy="2240280"/>
+          </a:xfrm>
+          <a:prstGeom prst="rect">
+            <a:avLst/>
+          </a:prstGeom>
+        </p:spPr>
+      </p:pic>
+      <p:pic>
+        <p:nvPicPr>
+          <p:cNvPr id="20" name="Picture 19" descr="image.png"/>
+          <p:cNvPicPr>
+            <a:picLocks noChangeAspect="1"/>
+          </p:cNvPicPr>
+          <p:nvPr/>
+        </p:nvPicPr>
+        <p:blipFill>
+          <a:blip r:embed="rId1"/>
+          <a:stretch>
+            <a:fillRect/>
+          </a:stretch>
+        </p:blipFill>
+        <p:spPr>
+          <a:xfrm>
+            <a:off x="4023360" y="4297680"/>
+            <a:ext cx="3840480" cy="1554480"/>
+          </a:xfrm>
+          <a:prstGeom prst="rect">
+            <a:avLst/>
+          </a:prstGeom>
+        </p:spPr>
+      </p:pic>
     </p:spTree>
   </p:cSld>
   <p:clrMapOvr>
@@ -2822,6 +2827,10 @@
           </a:solidFill>
           <a:ln/>
         </p:spPr>
+        <p:txBody>
+          <a:bodyPr/>
+          <a:p/>
+        </p:txBody>
       </p:sp>
       <p:sp>
         <p:nvSpPr>
@@ -2901,29 +2910,6 @@
           </a:p>
         </p:txBody>
       </p:sp>
-      <p:pic>
-        <p:nvPicPr>
-          <p:cNvPr id="5" name="Image 0" descr="/sessions/modest-trusting-fermi/mnt/outputs/slide_assets/cross_model.png">    </p:cNvPr>
-          <p:cNvPicPr>
-            <a:picLocks noChangeAspect="1"/>
-          </p:cNvPicPr>
-          <p:nvPr/>
-        </p:nvPicPr>
-        <p:blipFill>
-          <a:blip r:embed="rId1"/>
-          <a:srcRect l="0" r="0" t="0" b="0"/>
-          <a:stretch/>
-        </p:blipFill>
-        <p:spPr>
-          <a:xfrm>
-            <a:off x="731520" y="1691640"/>
-            <a:ext cx="7315200" cy="4114800"/>
-          </a:xfrm>
-          <a:prstGeom prst="rect">
-            <a:avLst/>
-          </a:prstGeom>
-        </p:spPr>
-      </p:pic>
       <p:sp>
         <p:nvSpPr>
           <p:cNvPr id="6" name="Text 3"/>
@@ -3087,6 +3073,30 @@
           </a:p>
         </p:txBody>
       </p:sp>
+      <p:pic>
+        <p:nvPicPr>
+          <p:cNvPr id="9" name="Picture 8" descr="fig_results_comparison.png"/>
+          <p:cNvPicPr>
+            <a:picLocks noChangeAspect="1"/>
+          </p:cNvPicPr>
+          <p:nvPr/>
+        </p:nvPicPr>
+        <p:blipFill>
+          <a:blip r:embed="rId4"/>
+          <a:stretch>
+            <a:fillRect/>
+          </a:stretch>
+        </p:blipFill>
+        <p:spPr>
+          <a:xfrm>
+            <a:off x="731520" y="1691640"/>
+            <a:ext cx="7315200" cy="4114800"/>
+          </a:xfrm>
+          <a:prstGeom prst="rect">
+            <a:avLst/>
+          </a:prstGeom>
+        </p:spPr>
+      </p:pic>
     </p:spTree>
   </p:cSld>
   <p:clrMapOvr>
@@ -3138,6 +3148,10 @@
           </a:solidFill>
           <a:ln/>
         </p:spPr>
+        <p:txBody>
+          <a:bodyPr/>
+          <a:p/>
+        </p:txBody>
       </p:sp>
       <p:sp>
         <p:nvSpPr>
@@ -3211,7 +3225,7 @@
                 <a:ea typeface="Trebuchet MS" pitchFamily="34" charset="-122"/>
                 <a:cs typeface="Trebuchet MS" pitchFamily="34" charset="-120"/>
               </a:rPr>
-              <a:t>A high AUC does not mean a usable detector</a:t>
+              <a:t>High AUC = good ranking — but the default threshold may need calibration</a:t>
             </a:r>
             <a:endParaRPr lang="en-US" sz="2800" dirty="0"/>
           </a:p>
@@ -3250,7 +3264,7 @@
                 <a:ea typeface="Calibri" pitchFamily="34" charset="-122"/>
                 <a:cs typeface="Calibri" pitchFamily="34" charset="-120"/>
               </a:rPr>
-              <a:t>On the imbalanced ITW set, weak models ride the 'real' majority to passable accuracy while missing most fakes. Fake-class recall exposes this.</a:t>
+              <a:t>AUC measures ranking quality (threshold-free). Low fake-recall at the default 0.5 threshold is a calibration problem, not a modelling failure — it can be fixed by tuning the threshold. A low-AUC model cannot be rescued by calibration alone.</a:t>
             </a:r>
             <a:endParaRPr lang="en-US" sz="1600" dirty="0"/>
           </a:p>
@@ -3258,682 +3272,823 @@
       </p:sp>
       <p:sp>
         <p:nvSpPr>
-          <p:cNvPr id="6" name="Shape 4"/>
+          <p:cNvPr id="21" name="Text 19"/>
+          <p:cNvSpPr/>
+          <p:nvPr/>
+        </p:nvSpPr>
+        <p:spPr>
+          <a:xfrm>
+            <a:off x="822960" y="4617720"/>
+            <a:ext cx="10515600" cy="365760"/>
+          </a:xfrm>
+          <a:prstGeom prst="rect">
+            <a:avLst/>
+          </a:prstGeom>
+          <a:noFill/>
+          <a:ln/>
+        </p:spPr>
+        <p:txBody>
+          <a:bodyPr wrap="square" lIns="0" tIns="0" rIns="0" bIns="0" rtlCol="0" anchor="ctr"/>
+          <a:lstStyle/>
+          <a:p>
+            <a:pPr indent="0" marL="0">
+              <a:buNone/>
+            </a:pPr>
+            <a:r>
+              <a:rPr lang="en-US" sz="1200" i="1" dirty="0">
+                <a:solidFill>
+                  <a:srgbClr val="6B7B85"/>
+                </a:solidFill>
+                <a:latin typeface="Calibri" pitchFamily="34" charset="0"/>
+                <a:ea typeface="Calibri" pitchFamily="34" charset="-122"/>
+                <a:cs typeface="Calibri" pitchFamily="34" charset="-120"/>
+              </a:rPr>
+              <a:t>Fraction of fake clips actually caught (ITW fake-class recall)</a:t>
+            </a:r>
+            <a:endParaRPr lang="en-US" sz="1200" dirty="0"/>
+          </a:p>
+        </p:txBody>
+      </p:sp>
+      <p:sp>
+        <p:nvSpPr>
+          <p:cNvPr id="22" name="Text 20"/>
+          <p:cNvSpPr/>
+          <p:nvPr/>
+        </p:nvSpPr>
+        <p:spPr>
+          <a:xfrm>
+            <a:off x="822960" y="5212080"/>
+            <a:ext cx="10515600" cy="457200"/>
+          </a:xfrm>
+          <a:prstGeom prst="rect">
+            <a:avLst/>
+          </a:prstGeom>
+          <a:noFill/>
+          <a:ln/>
+        </p:spPr>
+        <p:txBody>
+          <a:bodyPr wrap="square" lIns="0" tIns="0" rIns="0" bIns="0" rtlCol="0" anchor="ctr"/>
+          <a:lstStyle/>
+          <a:p>
+            <a:pPr indent="0" marL="0">
+              <a:buNone/>
+            </a:pPr>
+            <a:r>
+              <a:rPr lang="en-US" sz="1500" b="1" dirty="0">
+                <a:solidFill>
+                  <a:srgbClr val="22303A"/>
+                </a:solidFill>
+                <a:latin typeface="Trebuchet MS" pitchFamily="34" charset="0"/>
+                <a:ea typeface="Trebuchet MS" pitchFamily="34" charset="-122"/>
+                <a:cs typeface="Trebuchet MS" pitchFamily="34" charset="-120"/>
+              </a:rPr>
+              <a:t>→ CNN and WavLM probe combine high AUC with good out-of-the-box calibration. WavLM fine-tune has high AUC but collapses at threshold 0.5 under domain shift — threshold tuning would recover much of its fake-recall.</a:t>
+            </a:r>
+            <a:endParaRPr lang="en-US" sz="1500" dirty="0"/>
+          </a:p>
+        </p:txBody>
+      </p:sp>
+      <p:sp>
+        <p:nvSpPr>
+          <p:cNvPr id="23" name="Text 21"/>
+          <p:cNvSpPr/>
+          <p:nvPr/>
+        </p:nvSpPr>
+        <p:spPr>
+          <a:xfrm>
+            <a:off x="548640" y="6437376"/>
+            <a:ext cx="7315200" cy="274320"/>
+          </a:xfrm>
+          <a:prstGeom prst="rect">
+            <a:avLst/>
+          </a:prstGeom>
+          <a:noFill/>
+          <a:ln/>
+        </p:spPr>
+        <p:txBody>
+          <a:bodyPr wrap="square" lIns="0" tIns="0" rIns="0" bIns="0" rtlCol="0" anchor="ctr"/>
+          <a:lstStyle/>
+          <a:p>
+            <a:pPr indent="0" marL="0">
+              <a:buNone/>
+            </a:pPr>
+            <a:r>
+              <a:rPr lang="en-US" sz="900" dirty="0">
+                <a:solidFill>
+                  <a:srgbClr val="6B7B85"/>
+                </a:solidFill>
+                <a:latin typeface="Calibri" pitchFamily="34" charset="0"/>
+                <a:ea typeface="Calibri" pitchFamily="34" charset="-122"/>
+                <a:cs typeface="Calibri" pitchFamily="34" charset="-120"/>
+              </a:rPr>
+              <a:t>Audio Deepfake Detection — DL project</a:t>
+            </a:r>
+            <a:endParaRPr lang="en-US" sz="900" dirty="0"/>
+          </a:p>
+        </p:txBody>
+      </p:sp>
+      <p:sp>
+        <p:nvSpPr>
+          <p:cNvPr id="24" name="Text 22"/>
+          <p:cNvSpPr/>
+          <p:nvPr/>
+        </p:nvSpPr>
+        <p:spPr>
+          <a:xfrm>
+            <a:off x="11430000" y="6437376"/>
+            <a:ext cx="548640" cy="274320"/>
+          </a:xfrm>
+          <a:prstGeom prst="rect">
+            <a:avLst/>
+          </a:prstGeom>
+          <a:noFill/>
+          <a:ln/>
+        </p:spPr>
+        <p:txBody>
+          <a:bodyPr wrap="square" lIns="0" tIns="0" rIns="0" bIns="0" rtlCol="0" anchor="ctr"/>
+          <a:lstStyle/>
+          <a:p>
+            <a:pPr algn="r" indent="0" marL="0">
+              <a:buNone/>
+            </a:pPr>
+            <a:r>
+              <a:rPr lang="en-US" sz="900" dirty="0">
+                <a:solidFill>
+                  <a:srgbClr val="6B7B85"/>
+                </a:solidFill>
+                <a:latin typeface="Calibri" pitchFamily="34" charset="0"/>
+                <a:ea typeface="Calibri" pitchFamily="34" charset="-122"/>
+                <a:cs typeface="Calibri" pitchFamily="34" charset="-120"/>
+              </a:rPr>
+              <a:t>12</a:t>
+            </a:r>
+            <a:endParaRPr lang="en-US" sz="900" dirty="0"/>
+          </a:p>
+        </p:txBody>
+      </p:sp>
+      <p:sp>
+        <p:nvSpPr>
+          <p:cNvPr id="25" name="Rectangle 24"/>
           <p:cNvSpPr/>
           <p:nvPr/>
         </p:nvSpPr>
         <p:spPr>
           <a:xfrm>
             <a:off x="822960" y="2651760"/>
-            <a:ext cx="2057400" cy="1828800"/>
-          </a:xfrm>
-          <a:prstGeom prst="roundRect">
-            <a:avLst>
-              <a:gd name="adj" fmla="val 4000"/>
-            </a:avLst>
+            <a:ext cx="1700000" cy="1828800"/>
+          </a:xfrm>
+          <a:prstGeom prst="rect">
+            <a:avLst/>
           </a:prstGeom>
           <a:solidFill>
             <a:srgbClr val="F4F7F8"/>
           </a:solidFill>
-          <a:ln w="12700">
-            <a:solidFill>
-              <a:srgbClr val="DDE5E9"/>
-            </a:solidFill>
-            <a:prstDash val="solid"/>
+          <a:ln>
+            <a:noFill/>
           </a:ln>
         </p:spPr>
-      </p:sp>
-      <p:sp>
-        <p:nvSpPr>
-          <p:cNvPr id="7" name="Text 5"/>
-          <p:cNvSpPr/>
+        <p:style>
+          <a:lnRef idx="1">
+            <a:schemeClr val="accent1"/>
+          </a:lnRef>
+          <a:fillRef idx="3">
+            <a:schemeClr val="accent1"/>
+          </a:fillRef>
+          <a:effectRef idx="2">
+            <a:schemeClr val="accent1"/>
+          </a:effectRef>
+          <a:fontRef idx="minor">
+            <a:schemeClr val="lt1"/>
+          </a:fontRef>
+        </p:style>
+        <p:txBody>
+          <a:bodyPr rtlCol="0" anchor="ctr"/>
+          <a:lstStyle/>
+          <a:p>
+            <a:pPr algn="ctr"/>
+          </a:p>
+        </p:txBody>
+      </p:sp>
+      <p:sp>
+        <p:nvSpPr>
+          <p:cNvPr id="26" name="TextBox 25"/>
+          <p:cNvSpPr txBox="1"/>
           <p:nvPr/>
         </p:nvSpPr>
         <p:spPr>
           <a:xfrm>
             <a:off x="822960" y="2880360"/>
-            <a:ext cx="2057400" cy="822960"/>
-          </a:xfrm>
-          <a:prstGeom prst="rect">
-            <a:avLst/>
-          </a:prstGeom>
-          <a:noFill/>
-          <a:ln/>
-        </p:spPr>
-        <p:txBody>
-          <a:bodyPr wrap="square" lIns="0" tIns="0" rIns="0" bIns="0" rtlCol="0" anchor="ctr"/>
-          <a:lstStyle/>
-          <a:p>
-            <a:pPr algn="ctr" indent="0" marL="0">
-              <a:buNone/>
-            </a:pPr>
-            <a:r>
-              <a:rPr lang="en-US" sz="3800" b="1" dirty="0">
+            <a:ext cx="1700000" cy="822960"/>
+          </a:xfrm>
+          <a:prstGeom prst="rect">
+            <a:avLst/>
+          </a:prstGeom>
+          <a:noFill/>
+        </p:spPr>
+        <p:txBody>
+          <a:bodyPr wrap="none">
+            <a:spAutoFit/>
+          </a:bodyPr>
+          <a:lstStyle/>
+          <a:p>
+            <a:pPr algn="ctr"/>
+            <a:r>
+              <a:rPr b="1" sz="3600">
                 <a:solidFill>
                   <a:srgbClr val="0E9594"/>
                 </a:solidFill>
-                <a:latin typeface="Trebuchet MS" pitchFamily="34" charset="0"/>
-                <a:ea typeface="Trebuchet MS" pitchFamily="34" charset="-122"/>
-                <a:cs typeface="Trebuchet MS" pitchFamily="34" charset="-120"/>
               </a:rPr>
               <a:t>72%</a:t>
             </a:r>
-            <a:endParaRPr lang="en-US" sz="3800" dirty="0"/>
-          </a:p>
-        </p:txBody>
-      </p:sp>
-      <p:sp>
-        <p:nvSpPr>
-          <p:cNvPr id="8" name="Text 6"/>
-          <p:cNvSpPr/>
-          <p:nvPr/>
-        </p:nvSpPr>
-        <p:spPr>
-          <a:xfrm>
-            <a:off x="914400" y="3794760"/>
-            <a:ext cx="1874520" cy="548640"/>
-          </a:xfrm>
-          <a:prstGeom prst="rect">
-            <a:avLst/>
-          </a:prstGeom>
-          <a:noFill/>
-          <a:ln/>
-        </p:spPr>
-        <p:txBody>
-          <a:bodyPr wrap="square" lIns="0" tIns="0" rIns="0" bIns="0" rtlCol="0" anchor="ctr"/>
-          <a:lstStyle/>
-          <a:p>
-            <a:pPr algn="ctr" indent="0" marL="0">
-              <a:buNone/>
-            </a:pPr>
-            <a:r>
-              <a:rPr lang="en-US" sz="1300" dirty="0">
+          </a:p>
+        </p:txBody>
+      </p:sp>
+      <p:sp>
+        <p:nvSpPr>
+          <p:cNvPr id="27" name="TextBox 26"/>
+          <p:cNvSpPr txBox="1"/>
+          <p:nvPr/>
+        </p:nvSpPr>
+        <p:spPr>
+          <a:xfrm>
+            <a:off x="822960" y="3794760"/>
+            <a:ext cx="1700000" cy="548640"/>
+          </a:xfrm>
+          <a:prstGeom prst="rect">
+            <a:avLst/>
+          </a:prstGeom>
+          <a:noFill/>
+        </p:spPr>
+        <p:txBody>
+          <a:bodyPr wrap="none">
+            <a:spAutoFit/>
+          </a:bodyPr>
+          <a:lstStyle/>
+          <a:p>
+            <a:pPr algn="ctr"/>
+            <a:r>
+              <a:rPr b="0" sz="1300">
                 <a:solidFill>
                   <a:srgbClr val="6B7B85"/>
                 </a:solidFill>
-                <a:latin typeface="Calibri" pitchFamily="34" charset="0"/>
-                <a:ea typeface="Calibri" pitchFamily="34" charset="-122"/>
-                <a:cs typeface="Calibri" pitchFamily="34" charset="-120"/>
               </a:rPr>
               <a:t>CNN</a:t>
             </a:r>
-            <a:endParaRPr lang="en-US" sz="1300" dirty="0"/>
-          </a:p>
-        </p:txBody>
-      </p:sp>
-      <p:sp>
-        <p:nvSpPr>
-          <p:cNvPr id="9" name="Shape 7"/>
-          <p:cNvSpPr/>
-          <p:nvPr/>
-        </p:nvSpPr>
-        <p:spPr>
-          <a:xfrm>
-            <a:off x="3063240" y="2651760"/>
-            <a:ext cx="2057400" cy="1828800"/>
-          </a:xfrm>
-          <a:prstGeom prst="roundRect">
-            <a:avLst>
-              <a:gd name="adj" fmla="val 4000"/>
-            </a:avLst>
+          </a:p>
+        </p:txBody>
+      </p:sp>
+      <p:sp>
+        <p:nvSpPr>
+          <p:cNvPr id="28" name="Rectangle 27"/>
+          <p:cNvSpPr/>
+          <p:nvPr/>
+        </p:nvSpPr>
+        <p:spPr>
+          <a:xfrm>
+            <a:off x="2586080" y="2651760"/>
+            <a:ext cx="1700000" cy="1828800"/>
+          </a:xfrm>
+          <a:prstGeom prst="rect">
+            <a:avLst/>
           </a:prstGeom>
           <a:solidFill>
             <a:srgbClr val="F4F7F8"/>
           </a:solidFill>
-          <a:ln w="12700">
-            <a:solidFill>
-              <a:srgbClr val="DDE5E9"/>
-            </a:solidFill>
-            <a:prstDash val="solid"/>
+          <a:ln>
+            <a:noFill/>
           </a:ln>
         </p:spPr>
-      </p:sp>
-      <p:sp>
-        <p:nvSpPr>
-          <p:cNvPr id="10" name="Text 8"/>
-          <p:cNvSpPr/>
-          <p:nvPr/>
-        </p:nvSpPr>
-        <p:spPr>
-          <a:xfrm>
-            <a:off x="3063240" y="2880360"/>
-            <a:ext cx="2057400" cy="822960"/>
-          </a:xfrm>
-          <a:prstGeom prst="rect">
-            <a:avLst/>
-          </a:prstGeom>
-          <a:noFill/>
-          <a:ln/>
-        </p:spPr>
-        <p:txBody>
-          <a:bodyPr wrap="square" lIns="0" tIns="0" rIns="0" bIns="0" rtlCol="0" anchor="ctr"/>
-          <a:lstStyle/>
-          <a:p>
-            <a:pPr algn="ctr" indent="0" marL="0">
-              <a:buNone/>
-            </a:pPr>
-            <a:r>
-              <a:rPr lang="en-US" sz="3800" b="1" dirty="0">
-                <a:solidFill>
-                  <a:srgbClr val="3E7CB1"/>
-                </a:solidFill>
-                <a:latin typeface="Trebuchet MS" pitchFamily="34" charset="0"/>
-                <a:ea typeface="Trebuchet MS" pitchFamily="34" charset="-122"/>
-                <a:cs typeface="Trebuchet MS" pitchFamily="34" charset="-120"/>
-              </a:rPr>
-              <a:t>54%</a:t>
-            </a:r>
-            <a:endParaRPr lang="en-US" sz="3800" dirty="0"/>
-          </a:p>
-        </p:txBody>
-      </p:sp>
-      <p:sp>
-        <p:nvSpPr>
-          <p:cNvPr id="11" name="Text 9"/>
-          <p:cNvSpPr/>
-          <p:nvPr/>
-        </p:nvSpPr>
-        <p:spPr>
-          <a:xfrm>
-            <a:off x="3154680" y="3794760"/>
-            <a:ext cx="1874520" cy="548640"/>
-          </a:xfrm>
-          <a:prstGeom prst="rect">
-            <a:avLst/>
-          </a:prstGeom>
-          <a:noFill/>
-          <a:ln/>
-        </p:spPr>
-        <p:txBody>
-          <a:bodyPr wrap="square" lIns="0" tIns="0" rIns="0" bIns="0" rtlCol="0" anchor="ctr"/>
-          <a:lstStyle/>
-          <a:p>
-            <a:pPr algn="ctr" indent="0" marL="0">
-              <a:buNone/>
-            </a:pPr>
-            <a:r>
-              <a:rPr lang="en-US" sz="1300" dirty="0">
+        <p:style>
+          <a:lnRef idx="1">
+            <a:schemeClr val="accent1"/>
+          </a:lnRef>
+          <a:fillRef idx="3">
+            <a:schemeClr val="accent1"/>
+          </a:fillRef>
+          <a:effectRef idx="2">
+            <a:schemeClr val="accent1"/>
+          </a:effectRef>
+          <a:fontRef idx="minor">
+            <a:schemeClr val="lt1"/>
+          </a:fontRef>
+        </p:style>
+        <p:txBody>
+          <a:bodyPr rtlCol="0" anchor="ctr"/>
+          <a:lstStyle/>
+          <a:p>
+            <a:pPr algn="ctr"/>
+          </a:p>
+        </p:txBody>
+      </p:sp>
+      <p:sp>
+        <p:nvSpPr>
+          <p:cNvPr id="29" name="TextBox 28"/>
+          <p:cNvSpPr txBox="1"/>
+          <p:nvPr/>
+        </p:nvSpPr>
+        <p:spPr>
+          <a:xfrm>
+            <a:off x="2586080" y="2880360"/>
+            <a:ext cx="1700000" cy="822960"/>
+          </a:xfrm>
+          <a:prstGeom prst="rect">
+            <a:avLst/>
+          </a:prstGeom>
+          <a:noFill/>
+        </p:spPr>
+        <p:txBody>
+          <a:bodyPr wrap="none">
+            <a:spAutoFit/>
+          </a:bodyPr>
+          <a:lstStyle/>
+          <a:p>
+            <a:pPr algn="ctr"/>
+            <a:r>
+              <a:rPr b="1" sz="3600">
+                <a:solidFill>
+                  <a:srgbClr val="8E7CC3"/>
+                </a:solidFill>
+              </a:rPr>
+              <a:t>57%</a:t>
+            </a:r>
+          </a:p>
+        </p:txBody>
+      </p:sp>
+      <p:sp>
+        <p:nvSpPr>
+          <p:cNvPr id="30" name="TextBox 29"/>
+          <p:cNvSpPr txBox="1"/>
+          <p:nvPr/>
+        </p:nvSpPr>
+        <p:spPr>
+          <a:xfrm>
+            <a:off x="2586080" y="3794760"/>
+            <a:ext cx="1700000" cy="548640"/>
+          </a:xfrm>
+          <a:prstGeom prst="rect">
+            <a:avLst/>
+          </a:prstGeom>
+          <a:noFill/>
+        </p:spPr>
+        <p:txBody>
+          <a:bodyPr wrap="none">
+            <a:spAutoFit/>
+          </a:bodyPr>
+          <a:lstStyle/>
+          <a:p>
+            <a:pPr algn="ctr"/>
+            <a:r>
+              <a:rPr b="0" sz="1300">
                 <a:solidFill>
                   <a:srgbClr val="6B7B85"/>
                 </a:solidFill>
-                <a:latin typeface="Calibri" pitchFamily="34" charset="0"/>
-                <a:ea typeface="Calibri" pitchFamily="34" charset="-122"/>
-                <a:cs typeface="Calibri" pitchFamily="34" charset="-120"/>
-              </a:rPr>
-              <a:t>CRNN</a:t>
-            </a:r>
-            <a:endParaRPr lang="en-US" sz="1300" dirty="0"/>
-          </a:p>
-        </p:txBody>
-      </p:sp>
-      <p:sp>
-        <p:nvSpPr>
-          <p:cNvPr id="12" name="Shape 10"/>
-          <p:cNvSpPr/>
-          <p:nvPr/>
-        </p:nvSpPr>
-        <p:spPr>
-          <a:xfrm>
-            <a:off x="5303520" y="2651760"/>
-            <a:ext cx="2057400" cy="1828800"/>
-          </a:xfrm>
-          <a:prstGeom prst="roundRect">
-            <a:avLst>
-              <a:gd name="adj" fmla="val 4000"/>
-            </a:avLst>
+              </a:rPr>
+              <a:t>WavLM probe</a:t>
+            </a:r>
+          </a:p>
+        </p:txBody>
+      </p:sp>
+      <p:sp>
+        <p:nvSpPr>
+          <p:cNvPr id="31" name="Rectangle 30"/>
+          <p:cNvSpPr/>
+          <p:nvPr/>
+        </p:nvSpPr>
+        <p:spPr>
+          <a:xfrm>
+            <a:off x="4349200" y="2651760"/>
+            <a:ext cx="1700000" cy="1828800"/>
+          </a:xfrm>
+          <a:prstGeom prst="rect">
+            <a:avLst/>
           </a:prstGeom>
           <a:solidFill>
             <a:srgbClr val="F4F7F8"/>
           </a:solidFill>
-          <a:ln w="12700">
-            <a:solidFill>
-              <a:srgbClr val="DDE5E9"/>
-            </a:solidFill>
-            <a:prstDash val="solid"/>
+          <a:ln>
+            <a:noFill/>
           </a:ln>
         </p:spPr>
-      </p:sp>
-      <p:sp>
-        <p:nvSpPr>
-          <p:cNvPr id="13" name="Text 11"/>
-          <p:cNvSpPr/>
-          <p:nvPr/>
-        </p:nvSpPr>
-        <p:spPr>
-          <a:xfrm>
-            <a:off x="5303520" y="2880360"/>
-            <a:ext cx="2057400" cy="822960"/>
-          </a:xfrm>
-          <a:prstGeom prst="rect">
-            <a:avLst/>
-          </a:prstGeom>
-          <a:noFill/>
-          <a:ln/>
-        </p:spPr>
-        <p:txBody>
-          <a:bodyPr wrap="square" lIns="0" tIns="0" rIns="0" bIns="0" rtlCol="0" anchor="ctr"/>
-          <a:lstStyle/>
-          <a:p>
-            <a:pPr algn="ctr" indent="0" marL="0">
-              <a:buNone/>
-            </a:pPr>
-            <a:r>
-              <a:rPr lang="en-US" sz="3800" b="1" dirty="0">
-                <a:solidFill>
-                  <a:srgbClr val="C9971B"/>
-                </a:solidFill>
-                <a:latin typeface="Trebuchet MS" pitchFamily="34" charset="0"/>
-                <a:ea typeface="Trebuchet MS" pitchFamily="34" charset="-122"/>
-                <a:cs typeface="Trebuchet MS" pitchFamily="34" charset="-120"/>
-              </a:rPr>
-              <a:t>45%</a:t>
-            </a:r>
-            <a:endParaRPr lang="en-US" sz="3800" dirty="0"/>
-          </a:p>
-        </p:txBody>
-      </p:sp>
-      <p:sp>
-        <p:nvSpPr>
-          <p:cNvPr id="14" name="Text 12"/>
-          <p:cNvSpPr/>
-          <p:nvPr/>
-        </p:nvSpPr>
-        <p:spPr>
-          <a:xfrm>
-            <a:off x="5394960" y="3794760"/>
-            <a:ext cx="1874520" cy="548640"/>
-          </a:xfrm>
-          <a:prstGeom prst="rect">
-            <a:avLst/>
-          </a:prstGeom>
-          <a:noFill/>
-          <a:ln/>
-        </p:spPr>
-        <p:txBody>
-          <a:bodyPr wrap="square" lIns="0" tIns="0" rIns="0" bIns="0" rtlCol="0" anchor="ctr"/>
-          <a:lstStyle/>
-          <a:p>
-            <a:pPr algn="ctr" indent="0" marL="0">
-              <a:buNone/>
-            </a:pPr>
-            <a:r>
-              <a:rPr lang="en-US" sz="1300" dirty="0">
+        <p:style>
+          <a:lnRef idx="1">
+            <a:schemeClr val="accent1"/>
+          </a:lnRef>
+          <a:fillRef idx="3">
+            <a:schemeClr val="accent1"/>
+          </a:fillRef>
+          <a:effectRef idx="2">
+            <a:schemeClr val="accent1"/>
+          </a:effectRef>
+          <a:fontRef idx="minor">
+            <a:schemeClr val="lt1"/>
+          </a:fontRef>
+        </p:style>
+        <p:txBody>
+          <a:bodyPr rtlCol="0" anchor="ctr"/>
+          <a:lstStyle/>
+          <a:p>
+            <a:pPr algn="ctr"/>
+          </a:p>
+        </p:txBody>
+      </p:sp>
+      <p:sp>
+        <p:nvSpPr>
+          <p:cNvPr id="32" name="TextBox 31"/>
+          <p:cNvSpPr txBox="1"/>
+          <p:nvPr/>
+        </p:nvSpPr>
+        <p:spPr>
+          <a:xfrm>
+            <a:off x="4349200" y="2880360"/>
+            <a:ext cx="1700000" cy="822960"/>
+          </a:xfrm>
+          <a:prstGeom prst="rect">
+            <a:avLst/>
+          </a:prstGeom>
+          <a:noFill/>
+        </p:spPr>
+        <p:txBody>
+          <a:bodyPr wrap="none">
+            <a:spAutoFit/>
+          </a:bodyPr>
+          <a:lstStyle/>
+          <a:p>
+            <a:pPr algn="ctr"/>
+            <a:r>
+              <a:rPr b="1" sz="3600">
+                <a:solidFill>
+                  <a:srgbClr val="3E7CB1"/>
+                </a:solidFill>
+              </a:rPr>
+              <a:t>54%</a:t>
+            </a:r>
+          </a:p>
+        </p:txBody>
+      </p:sp>
+      <p:sp>
+        <p:nvSpPr>
+          <p:cNvPr id="33" name="TextBox 32"/>
+          <p:cNvSpPr txBox="1"/>
+          <p:nvPr/>
+        </p:nvSpPr>
+        <p:spPr>
+          <a:xfrm>
+            <a:off x="4349200" y="3794760"/>
+            <a:ext cx="1700000" cy="548640"/>
+          </a:xfrm>
+          <a:prstGeom prst="rect">
+            <a:avLst/>
+          </a:prstGeom>
+          <a:noFill/>
+        </p:spPr>
+        <p:txBody>
+          <a:bodyPr wrap="none">
+            <a:spAutoFit/>
+          </a:bodyPr>
+          <a:lstStyle/>
+          <a:p>
+            <a:pPr algn="ctr"/>
+            <a:r>
+              <a:rPr b="0" sz="1300">
                 <a:solidFill>
                   <a:srgbClr val="6B7B85"/>
                 </a:solidFill>
-                <a:latin typeface="Calibri" pitchFamily="34" charset="0"/>
-                <a:ea typeface="Calibri" pitchFamily="34" charset="-122"/>
-                <a:cs typeface="Calibri" pitchFamily="34" charset="-120"/>
-              </a:rPr>
-              <a:t>WavLM ft</a:t>
-            </a:r>
-            <a:endParaRPr lang="en-US" sz="1300" dirty="0"/>
-          </a:p>
-        </p:txBody>
-      </p:sp>
-      <p:sp>
-        <p:nvSpPr>
-          <p:cNvPr id="15" name="Shape 13"/>
-          <p:cNvSpPr/>
-          <p:nvPr/>
-        </p:nvSpPr>
-        <p:spPr>
-          <a:xfrm>
-            <a:off x="7543800" y="2651760"/>
-            <a:ext cx="2057400" cy="1828800"/>
-          </a:xfrm>
-          <a:prstGeom prst="roundRect">
-            <a:avLst>
-              <a:gd name="adj" fmla="val 4000"/>
-            </a:avLst>
+              </a:rPr>
+              <a:t>CRNN</a:t>
+            </a:r>
+          </a:p>
+        </p:txBody>
+      </p:sp>
+      <p:sp>
+        <p:nvSpPr>
+          <p:cNvPr id="34" name="Rectangle 33"/>
+          <p:cNvSpPr/>
+          <p:nvPr/>
+        </p:nvSpPr>
+        <p:spPr>
+          <a:xfrm>
+            <a:off x="6112320" y="2651760"/>
+            <a:ext cx="1700000" cy="1828800"/>
+          </a:xfrm>
+          <a:prstGeom prst="rect">
+            <a:avLst/>
           </a:prstGeom>
           <a:solidFill>
             <a:srgbClr val="F4F7F8"/>
           </a:solidFill>
-          <a:ln w="12700">
-            <a:solidFill>
-              <a:srgbClr val="DDE5E9"/>
-            </a:solidFill>
-            <a:prstDash val="solid"/>
+          <a:ln>
+            <a:noFill/>
           </a:ln>
         </p:spPr>
-      </p:sp>
-      <p:sp>
-        <p:nvSpPr>
-          <p:cNvPr id="16" name="Text 14"/>
-          <p:cNvSpPr/>
-          <p:nvPr/>
-        </p:nvSpPr>
-        <p:spPr>
-          <a:xfrm>
-            <a:off x="7543800" y="2880360"/>
-            <a:ext cx="2057400" cy="822960"/>
-          </a:xfrm>
-          <a:prstGeom prst="rect">
-            <a:avLst/>
-          </a:prstGeom>
-          <a:noFill/>
-          <a:ln/>
-        </p:spPr>
-        <p:txBody>
-          <a:bodyPr wrap="square" lIns="0" tIns="0" rIns="0" bIns="0" rtlCol="0" anchor="ctr"/>
-          <a:lstStyle/>
-          <a:p>
-            <a:pPr algn="ctr" indent="0" marL="0">
-              <a:buNone/>
-            </a:pPr>
-            <a:r>
-              <a:rPr lang="en-US" sz="3800" b="1" dirty="0">
-                <a:solidFill>
-                  <a:srgbClr val="E8674F"/>
-                </a:solidFill>
-                <a:latin typeface="Trebuchet MS" pitchFamily="34" charset="0"/>
-                <a:ea typeface="Trebuchet MS" pitchFamily="34" charset="-122"/>
-                <a:cs typeface="Trebuchet MS" pitchFamily="34" charset="-120"/>
-              </a:rPr>
-              <a:t>17%</a:t>
-            </a:r>
-            <a:endParaRPr lang="en-US" sz="3800" dirty="0"/>
-          </a:p>
-        </p:txBody>
-      </p:sp>
-      <p:sp>
-        <p:nvSpPr>
-          <p:cNvPr id="17" name="Text 15"/>
-          <p:cNvSpPr/>
-          <p:nvPr/>
-        </p:nvSpPr>
-        <p:spPr>
-          <a:xfrm>
-            <a:off x="7635240" y="3794760"/>
-            <a:ext cx="1874520" cy="548640"/>
-          </a:xfrm>
-          <a:prstGeom prst="rect">
-            <a:avLst/>
-          </a:prstGeom>
-          <a:noFill/>
-          <a:ln/>
-        </p:spPr>
-        <p:txBody>
-          <a:bodyPr wrap="square" lIns="0" tIns="0" rIns="0" bIns="0" rtlCol="0" anchor="ctr"/>
-          <a:lstStyle/>
-          <a:p>
-            <a:pPr algn="ctr" indent="0" marL="0">
-              <a:buNone/>
-            </a:pPr>
-            <a:r>
-              <a:rPr lang="en-US" sz="1300" dirty="0">
+        <p:style>
+          <a:lnRef idx="1">
+            <a:schemeClr val="accent1"/>
+          </a:lnRef>
+          <a:fillRef idx="3">
+            <a:schemeClr val="accent1"/>
+          </a:fillRef>
+          <a:effectRef idx="2">
+            <a:schemeClr val="accent1"/>
+          </a:effectRef>
+          <a:fontRef idx="minor">
+            <a:schemeClr val="lt1"/>
+          </a:fontRef>
+        </p:style>
+        <p:txBody>
+          <a:bodyPr rtlCol="0" anchor="ctr"/>
+          <a:lstStyle/>
+          <a:p>
+            <a:pPr algn="ctr"/>
+          </a:p>
+        </p:txBody>
+      </p:sp>
+      <p:sp>
+        <p:nvSpPr>
+          <p:cNvPr id="35" name="TextBox 34"/>
+          <p:cNvSpPr txBox="1"/>
+          <p:nvPr/>
+        </p:nvSpPr>
+        <p:spPr>
+          <a:xfrm>
+            <a:off x="6112320" y="2880360"/>
+            <a:ext cx="1700000" cy="822960"/>
+          </a:xfrm>
+          <a:prstGeom prst="rect">
+            <a:avLst/>
+          </a:prstGeom>
+          <a:noFill/>
+        </p:spPr>
+        <p:txBody>
+          <a:bodyPr wrap="none">
+            <a:spAutoFit/>
+          </a:bodyPr>
+          <a:lstStyle/>
+          <a:p>
+            <a:pPr algn="ctr"/>
+            <a:r>
+              <a:rPr b="1" sz="3600">
+                <a:solidFill>
+                  <a:srgbClr val="C9971B"/>
+                </a:solidFill>
+              </a:rPr>
+              <a:t>45%</a:t>
+            </a:r>
+          </a:p>
+        </p:txBody>
+      </p:sp>
+      <p:sp>
+        <p:nvSpPr>
+          <p:cNvPr id="36" name="TextBox 35"/>
+          <p:cNvSpPr txBox="1"/>
+          <p:nvPr/>
+        </p:nvSpPr>
+        <p:spPr>
+          <a:xfrm>
+            <a:off x="6112320" y="3794760"/>
+            <a:ext cx="1700000" cy="548640"/>
+          </a:xfrm>
+          <a:prstGeom prst="rect">
+            <a:avLst/>
+          </a:prstGeom>
+          <a:noFill/>
+        </p:spPr>
+        <p:txBody>
+          <a:bodyPr wrap="none">
+            <a:spAutoFit/>
+          </a:bodyPr>
+          <a:lstStyle/>
+          <a:p>
+            <a:pPr algn="ctr"/>
+            <a:r>
+              <a:rPr b="0" sz="1300">
                 <a:solidFill>
                   <a:srgbClr val="6B7B85"/>
                 </a:solidFill>
-                <a:latin typeface="Calibri" pitchFamily="34" charset="0"/>
-                <a:ea typeface="Calibri" pitchFamily="34" charset="-122"/>
-                <a:cs typeface="Calibri" pitchFamily="34" charset="-120"/>
-              </a:rPr>
-              <a:t>MLP</a:t>
-            </a:r>
-            <a:endParaRPr lang="en-US" sz="1300" dirty="0"/>
-          </a:p>
-        </p:txBody>
-      </p:sp>
-      <p:sp>
-        <p:nvSpPr>
-          <p:cNvPr id="18" name="Shape 16"/>
-          <p:cNvSpPr/>
-          <p:nvPr/>
-        </p:nvSpPr>
-        <p:spPr>
-          <a:xfrm>
-            <a:off x="9784080" y="2651760"/>
-            <a:ext cx="2057400" cy="1828800"/>
-          </a:xfrm>
-          <a:prstGeom prst="roundRect">
-            <a:avLst>
-              <a:gd name="adj" fmla="val 4000"/>
-            </a:avLst>
+              </a:rPr>
+              <a:t>WavLM ft</a:t>
+            </a:r>
+          </a:p>
+        </p:txBody>
+      </p:sp>
+      <p:sp>
+        <p:nvSpPr>
+          <p:cNvPr id="37" name="Rectangle 36"/>
+          <p:cNvSpPr/>
+          <p:nvPr/>
+        </p:nvSpPr>
+        <p:spPr>
+          <a:xfrm>
+            <a:off x="7875440" y="2651760"/>
+            <a:ext cx="1700000" cy="1828800"/>
+          </a:xfrm>
+          <a:prstGeom prst="rect">
+            <a:avLst/>
           </a:prstGeom>
           <a:solidFill>
             <a:srgbClr val="F4F7F8"/>
           </a:solidFill>
-          <a:ln w="12700">
-            <a:solidFill>
-              <a:srgbClr val="DDE5E9"/>
-            </a:solidFill>
-            <a:prstDash val="solid"/>
+          <a:ln>
+            <a:noFill/>
           </a:ln>
         </p:spPr>
-      </p:sp>
-      <p:sp>
-        <p:nvSpPr>
-          <p:cNvPr id="19" name="Text 17"/>
-          <p:cNvSpPr/>
-          <p:nvPr/>
-        </p:nvSpPr>
-        <p:spPr>
-          <a:xfrm>
-            <a:off x="9784080" y="2880360"/>
-            <a:ext cx="2057400" cy="822960"/>
-          </a:xfrm>
-          <a:prstGeom prst="rect">
-            <a:avLst/>
-          </a:prstGeom>
-          <a:noFill/>
-          <a:ln/>
-        </p:spPr>
-        <p:txBody>
-          <a:bodyPr wrap="square" lIns="0" tIns="0" rIns="0" bIns="0" rtlCol="0" anchor="ctr"/>
-          <a:lstStyle/>
-          <a:p>
-            <a:pPr algn="ctr" indent="0" marL="0">
-              <a:buNone/>
-            </a:pPr>
-            <a:r>
-              <a:rPr lang="en-US" sz="3800" b="1" dirty="0">
+        <p:style>
+          <a:lnRef idx="1">
+            <a:schemeClr val="accent1"/>
+          </a:lnRef>
+          <a:fillRef idx="3">
+            <a:schemeClr val="accent1"/>
+          </a:fillRef>
+          <a:effectRef idx="2">
+            <a:schemeClr val="accent1"/>
+          </a:effectRef>
+          <a:fontRef idx="minor">
+            <a:schemeClr val="lt1"/>
+          </a:fontRef>
+        </p:style>
+        <p:txBody>
+          <a:bodyPr rtlCol="0" anchor="ctr"/>
+          <a:lstStyle/>
+          <a:p>
+            <a:pPr algn="ctr"/>
+          </a:p>
+        </p:txBody>
+      </p:sp>
+      <p:sp>
+        <p:nvSpPr>
+          <p:cNvPr id="38" name="TextBox 37"/>
+          <p:cNvSpPr txBox="1"/>
+          <p:nvPr/>
+        </p:nvSpPr>
+        <p:spPr>
+          <a:xfrm>
+            <a:off x="7875440" y="2880360"/>
+            <a:ext cx="1700000" cy="822960"/>
+          </a:xfrm>
+          <a:prstGeom prst="rect">
+            <a:avLst/>
+          </a:prstGeom>
+          <a:noFill/>
+        </p:spPr>
+        <p:txBody>
+          <a:bodyPr wrap="none">
+            <a:spAutoFit/>
+          </a:bodyPr>
+          <a:lstStyle/>
+          <a:p>
+            <a:pPr algn="ctr"/>
+            <a:r>
+              <a:rPr b="1" sz="3600">
                 <a:solidFill>
                   <a:srgbClr val="E8674F"/>
                 </a:solidFill>
-                <a:latin typeface="Trebuchet MS" pitchFamily="34" charset="0"/>
-                <a:ea typeface="Trebuchet MS" pitchFamily="34" charset="-122"/>
-                <a:cs typeface="Trebuchet MS" pitchFamily="34" charset="-120"/>
               </a:rPr>
               <a:t>17%</a:t>
             </a:r>
-            <a:endParaRPr lang="en-US" sz="3800" dirty="0"/>
-          </a:p>
-        </p:txBody>
-      </p:sp>
-      <p:sp>
-        <p:nvSpPr>
-          <p:cNvPr id="20" name="Text 18"/>
-          <p:cNvSpPr/>
-          <p:nvPr/>
-        </p:nvSpPr>
-        <p:spPr>
-          <a:xfrm>
-            <a:off x="9875520" y="3794760"/>
-            <a:ext cx="1874520" cy="548640"/>
-          </a:xfrm>
-          <a:prstGeom prst="rect">
-            <a:avLst/>
-          </a:prstGeom>
-          <a:noFill/>
-          <a:ln/>
-        </p:spPr>
-        <p:txBody>
-          <a:bodyPr wrap="square" lIns="0" tIns="0" rIns="0" bIns="0" rtlCol="0" anchor="ctr"/>
-          <a:lstStyle/>
-          <a:p>
-            <a:pPr algn="ctr" indent="0" marL="0">
-              <a:buNone/>
-            </a:pPr>
-            <a:r>
-              <a:rPr lang="en-US" sz="1300" dirty="0">
+          </a:p>
+        </p:txBody>
+      </p:sp>
+      <p:sp>
+        <p:nvSpPr>
+          <p:cNvPr id="39" name="TextBox 38"/>
+          <p:cNvSpPr txBox="1"/>
+          <p:nvPr/>
+        </p:nvSpPr>
+        <p:spPr>
+          <a:xfrm>
+            <a:off x="7875440" y="3794760"/>
+            <a:ext cx="1700000" cy="548640"/>
+          </a:xfrm>
+          <a:prstGeom prst="rect">
+            <a:avLst/>
+          </a:prstGeom>
+          <a:noFill/>
+        </p:spPr>
+        <p:txBody>
+          <a:bodyPr wrap="none">
+            <a:spAutoFit/>
+          </a:bodyPr>
+          <a:lstStyle/>
+          <a:p>
+            <a:pPr algn="ctr"/>
+            <a:r>
+              <a:rPr b="0" sz="1300">
                 <a:solidFill>
                   <a:srgbClr val="6B7B85"/>
                 </a:solidFill>
-                <a:latin typeface="Calibri" pitchFamily="34" charset="0"/>
-                <a:ea typeface="Calibri" pitchFamily="34" charset="-122"/>
-                <a:cs typeface="Calibri" pitchFamily="34" charset="-120"/>
+              </a:rPr>
+              <a:t>MLP</a:t>
+            </a:r>
+          </a:p>
+        </p:txBody>
+      </p:sp>
+      <p:sp>
+        <p:nvSpPr>
+          <p:cNvPr id="40" name="Rectangle 39"/>
+          <p:cNvSpPr/>
+          <p:nvPr/>
+        </p:nvSpPr>
+        <p:spPr>
+          <a:xfrm>
+            <a:off x="9638560" y="2651760"/>
+            <a:ext cx="1700000" cy="1828800"/>
+          </a:xfrm>
+          <a:prstGeom prst="rect">
+            <a:avLst/>
+          </a:prstGeom>
+          <a:solidFill>
+            <a:srgbClr val="F4F7F8"/>
+          </a:solidFill>
+          <a:ln>
+            <a:noFill/>
+          </a:ln>
+        </p:spPr>
+        <p:style>
+          <a:lnRef idx="1">
+            <a:schemeClr val="accent1"/>
+          </a:lnRef>
+          <a:fillRef idx="3">
+            <a:schemeClr val="accent1"/>
+          </a:fillRef>
+          <a:effectRef idx="2">
+            <a:schemeClr val="accent1"/>
+          </a:effectRef>
+          <a:fontRef idx="minor">
+            <a:schemeClr val="lt1"/>
+          </a:fontRef>
+        </p:style>
+        <p:txBody>
+          <a:bodyPr rtlCol="0" anchor="ctr"/>
+          <a:lstStyle/>
+          <a:p>
+            <a:pPr algn="ctr"/>
+          </a:p>
+        </p:txBody>
+      </p:sp>
+      <p:sp>
+        <p:nvSpPr>
+          <p:cNvPr id="41" name="TextBox 40"/>
+          <p:cNvSpPr txBox="1"/>
+          <p:nvPr/>
+        </p:nvSpPr>
+        <p:spPr>
+          <a:xfrm>
+            <a:off x="9638560" y="2880360"/>
+            <a:ext cx="1700000" cy="822960"/>
+          </a:xfrm>
+          <a:prstGeom prst="rect">
+            <a:avLst/>
+          </a:prstGeom>
+          <a:noFill/>
+        </p:spPr>
+        <p:txBody>
+          <a:bodyPr wrap="none">
+            <a:spAutoFit/>
+          </a:bodyPr>
+          <a:lstStyle/>
+          <a:p>
+            <a:pPr algn="ctr"/>
+            <a:r>
+              <a:rPr b="1" sz="3600">
+                <a:solidFill>
+                  <a:srgbClr val="E8674F"/>
+                </a:solidFill>
+              </a:rPr>
+              <a:t>17%</a:t>
+            </a:r>
+          </a:p>
+        </p:txBody>
+      </p:sp>
+      <p:sp>
+        <p:nvSpPr>
+          <p:cNvPr id="42" name="TextBox 41"/>
+          <p:cNvSpPr txBox="1"/>
+          <p:nvPr/>
+        </p:nvSpPr>
+        <p:spPr>
+          <a:xfrm>
+            <a:off x="9638560" y="3794760"/>
+            <a:ext cx="1700000" cy="548640"/>
+          </a:xfrm>
+          <a:prstGeom prst="rect">
+            <a:avLst/>
+          </a:prstGeom>
+          <a:noFill/>
+        </p:spPr>
+        <p:txBody>
+          <a:bodyPr wrap="none">
+            <a:spAutoFit/>
+          </a:bodyPr>
+          <a:lstStyle/>
+          <a:p>
+            <a:pPr algn="ctr"/>
+            <a:r>
+              <a:rPr b="0" sz="1300">
+                <a:solidFill>
+                  <a:srgbClr val="6B7B85"/>
+                </a:solidFill>
               </a:rPr>
               <a:t>RNN</a:t>
             </a:r>
-            <a:endParaRPr lang="en-US" sz="1300" dirty="0"/>
-          </a:p>
-        </p:txBody>
-      </p:sp>
-      <p:sp>
-        <p:nvSpPr>
-          <p:cNvPr id="21" name="Text 19"/>
-          <p:cNvSpPr/>
-          <p:nvPr/>
-        </p:nvSpPr>
-        <p:spPr>
-          <a:xfrm>
-            <a:off x="822960" y="4617720"/>
-            <a:ext cx="10515600" cy="365760"/>
-          </a:xfrm>
-          <a:prstGeom prst="rect">
-            <a:avLst/>
-          </a:prstGeom>
-          <a:noFill/>
-          <a:ln/>
-        </p:spPr>
-        <p:txBody>
-          <a:bodyPr wrap="square" lIns="0" tIns="0" rIns="0" bIns="0" rtlCol="0" anchor="ctr"/>
-          <a:lstStyle/>
-          <a:p>
-            <a:pPr indent="0" marL="0">
-              <a:buNone/>
-            </a:pPr>
-            <a:r>
-              <a:rPr lang="en-US" sz="1200" i="1" dirty="0">
-                <a:solidFill>
-                  <a:srgbClr val="6B7B85"/>
-                </a:solidFill>
-                <a:latin typeface="Calibri" pitchFamily="34" charset="0"/>
-                <a:ea typeface="Calibri" pitchFamily="34" charset="-122"/>
-                <a:cs typeface="Calibri" pitchFamily="34" charset="-120"/>
-              </a:rPr>
-              <a:t>Fraction of fake clips actually caught (ITW fake-class recall)</a:t>
-            </a:r>
-            <a:endParaRPr lang="en-US" sz="1200" dirty="0"/>
-          </a:p>
-        </p:txBody>
-      </p:sp>
-      <p:sp>
-        <p:nvSpPr>
-          <p:cNvPr id="22" name="Text 20"/>
-          <p:cNvSpPr/>
-          <p:nvPr/>
-        </p:nvSpPr>
-        <p:spPr>
-          <a:xfrm>
-            <a:off x="822960" y="5212080"/>
-            <a:ext cx="10515600" cy="457200"/>
-          </a:xfrm>
-          <a:prstGeom prst="rect">
-            <a:avLst/>
-          </a:prstGeom>
-          <a:noFill/>
-          <a:ln/>
-        </p:spPr>
-        <p:txBody>
-          <a:bodyPr wrap="square" lIns="0" tIns="0" rIns="0" bIns="0" rtlCol="0" anchor="ctr"/>
-          <a:lstStyle/>
-          <a:p>
-            <a:pPr indent="0" marL="0">
-              <a:buNone/>
-            </a:pPr>
-            <a:r>
-              <a:rPr lang="en-US" sz="1500" b="1" dirty="0">
-                <a:solidFill>
-                  <a:srgbClr val="22303A"/>
-                </a:solidFill>
-                <a:latin typeface="Trebuchet MS" pitchFamily="34" charset="0"/>
-                <a:ea typeface="Trebuchet MS" pitchFamily="34" charset="-122"/>
-                <a:cs typeface="Trebuchet MS" pitchFamily="34" charset="-120"/>
-              </a:rPr>
-              <a:t>→ Only the CNN and the frozen WavLM probe are both well-ranked AND operationally effective.</a:t>
-            </a:r>
-            <a:endParaRPr lang="en-US" sz="1500" dirty="0"/>
-          </a:p>
-        </p:txBody>
-      </p:sp>
-      <p:sp>
-        <p:nvSpPr>
-          <p:cNvPr id="23" name="Text 21"/>
-          <p:cNvSpPr/>
-          <p:nvPr/>
-        </p:nvSpPr>
-        <p:spPr>
-          <a:xfrm>
-            <a:off x="548640" y="6437376"/>
-            <a:ext cx="7315200" cy="274320"/>
-          </a:xfrm>
-          <a:prstGeom prst="rect">
-            <a:avLst/>
-          </a:prstGeom>
-          <a:noFill/>
-          <a:ln/>
-        </p:spPr>
-        <p:txBody>
-          <a:bodyPr wrap="square" lIns="0" tIns="0" rIns="0" bIns="0" rtlCol="0" anchor="ctr"/>
-          <a:lstStyle/>
-          <a:p>
-            <a:pPr indent="0" marL="0">
-              <a:buNone/>
-            </a:pPr>
-            <a:r>
-              <a:rPr lang="en-US" sz="900" dirty="0">
-                <a:solidFill>
-                  <a:srgbClr val="6B7B85"/>
-                </a:solidFill>
-                <a:latin typeface="Calibri" pitchFamily="34" charset="0"/>
-                <a:ea typeface="Calibri" pitchFamily="34" charset="-122"/>
-                <a:cs typeface="Calibri" pitchFamily="34" charset="-120"/>
-              </a:rPr>
-              <a:t>Audio Deepfake Detection — DL project</a:t>
-            </a:r>
-            <a:endParaRPr lang="en-US" sz="900" dirty="0"/>
-          </a:p>
-        </p:txBody>
-      </p:sp>
-      <p:sp>
-        <p:nvSpPr>
-          <p:cNvPr id="24" name="Text 22"/>
-          <p:cNvSpPr/>
-          <p:nvPr/>
-        </p:nvSpPr>
-        <p:spPr>
-          <a:xfrm>
-            <a:off x="11430000" y="6437376"/>
-            <a:ext cx="548640" cy="274320"/>
-          </a:xfrm>
-          <a:prstGeom prst="rect">
-            <a:avLst/>
-          </a:prstGeom>
-          <a:noFill/>
-          <a:ln/>
-        </p:spPr>
-        <p:txBody>
-          <a:bodyPr wrap="square" lIns="0" tIns="0" rIns="0" bIns="0" rtlCol="0" anchor="ctr"/>
-          <a:lstStyle/>
-          <a:p>
-            <a:pPr algn="r" indent="0" marL="0">
-              <a:buNone/>
-            </a:pPr>
-            <a:r>
-              <a:rPr lang="en-US" sz="900" dirty="0">
-                <a:solidFill>
-                  <a:srgbClr val="6B7B85"/>
-                </a:solidFill>
-                <a:latin typeface="Calibri" pitchFamily="34" charset="0"/>
-                <a:ea typeface="Calibri" pitchFamily="34" charset="-122"/>
-                <a:cs typeface="Calibri" pitchFamily="34" charset="-120"/>
-              </a:rPr>
-              <a:t>12</a:t>
-            </a:r>
-            <a:endParaRPr lang="en-US" sz="900" dirty="0"/>
           </a:p>
         </p:txBody>
       </p:sp>
@@ -3988,6 +4143,10 @@
           </a:solidFill>
           <a:ln/>
         </p:spPr>
+        <p:txBody>
+          <a:bodyPr/>
+          <a:p/>
+        </p:txBody>
       </p:sp>
       <p:sp>
         <p:nvSpPr>
@@ -4067,29 +4226,6 @@
           </a:p>
         </p:txBody>
       </p:sp>
-      <p:pic>
-        <p:nvPicPr>
-          <p:cNvPr id="5" name="Image 0" descr="/sessions/modest-trusting-fermi/mnt/outputs/slide_assets/gen_gap.png">    </p:cNvPr>
-          <p:cNvPicPr>
-            <a:picLocks noChangeAspect="1"/>
-          </p:cNvPicPr>
-          <p:nvPr/>
-        </p:nvPicPr>
-        <p:blipFill>
-          <a:blip r:embed="rId1"/>
-          <a:srcRect l="0" r="0" t="0" b="0"/>
-          <a:stretch/>
-        </p:blipFill>
-        <p:spPr>
-          <a:xfrm>
-            <a:off x="731520" y="1783080"/>
-            <a:ext cx="7132320" cy="3840480"/>
-          </a:xfrm>
-          <a:prstGeom prst="rect">
-            <a:avLst/>
-          </a:prstGeom>
-        </p:spPr>
-      </p:pic>
       <p:sp>
         <p:nvSpPr>
           <p:cNvPr id="6" name="Text 3"/>
@@ -4253,6 +4389,30 @@
           </a:p>
         </p:txBody>
       </p:sp>
+      <p:pic>
+        <p:nvPicPr>
+          <p:cNvPr id="9" name="Picture 8" descr="fig_gen_gap.png"/>
+          <p:cNvPicPr>
+            <a:picLocks noChangeAspect="1"/>
+          </p:cNvPicPr>
+          <p:nvPr/>
+        </p:nvPicPr>
+        <p:blipFill>
+          <a:blip r:embed="rId4"/>
+          <a:stretch>
+            <a:fillRect/>
+          </a:stretch>
+        </p:blipFill>
+        <p:spPr>
+          <a:xfrm>
+            <a:off x="731520" y="1783080"/>
+            <a:ext cx="7132320" cy="3840480"/>
+          </a:xfrm>
+          <a:prstGeom prst="rect">
+            <a:avLst/>
+          </a:prstGeom>
+        </p:spPr>
+      </p:pic>
     </p:spTree>
   </p:cSld>
   <p:clrMapOvr>
@@ -4304,6 +4464,10 @@
           </a:solidFill>
           <a:ln/>
         </p:spPr>
+        <p:txBody>
+          <a:bodyPr/>
+          <a:p/>
+        </p:txBody>
       </p:sp>
       <p:sp>
         <p:nvSpPr>
@@ -4409,6 +4573,10 @@
             <a:prstDash val="solid"/>
           </a:ln>
         </p:spPr>
+        <p:txBody>
+          <a:bodyPr/>
+          <a:p/>
+        </p:txBody>
       </p:sp>
       <p:sp>
         <p:nvSpPr>
@@ -4429,6 +4597,10 @@
           </a:solidFill>
           <a:ln/>
         </p:spPr>
+        <p:txBody>
+          <a:bodyPr/>
+          <a:p/>
+        </p:txBody>
       </p:sp>
       <p:sp>
         <p:nvSpPr>
@@ -4534,6 +4706,10 @@
             <a:prstDash val="solid"/>
           </a:ln>
         </p:spPr>
+        <p:txBody>
+          <a:bodyPr/>
+          <a:p/>
+        </p:txBody>
       </p:sp>
       <p:sp>
         <p:nvSpPr>
@@ -4554,6 +4730,10 @@
           </a:solidFill>
           <a:ln/>
         </p:spPr>
+        <p:txBody>
+          <a:bodyPr/>
+          <a:p/>
+        </p:txBody>
       </p:sp>
       <p:sp>
         <p:nvSpPr>
@@ -4801,6 +4981,10 @@
           </a:solidFill>
           <a:ln/>
         </p:spPr>
+        <p:txBody>
+          <a:bodyPr/>
+          <a:p/>
+        </p:txBody>
       </p:sp>
       <p:sp>
         <p:nvSpPr>
@@ -5061,6 +5245,237 @@
               <a:t>15</a:t>
             </a:r>
             <a:endParaRPr lang="en-US" sz="900" dirty="0"/>
+          </a:p>
+        </p:txBody>
+      </p:sp>
+    </p:spTree>
+  </p:cSld>
+  <p:clrMapOvr>
+    <a:masterClrMapping/>
+  </p:clrMapOvr>
+</p:sld>
+</file>
+
+<file path=ppt/slides/slide16.xml><?xml version="1.0" encoding="utf-8"?>
+<p:sld xmlns:a="http://schemas.openxmlformats.org/drawingml/2006/main" xmlns:p="http://schemas.openxmlformats.org/presentationml/2006/main" xmlns:r="http://schemas.openxmlformats.org/officeDocument/2006/relationships">
+  <p:cSld>
+    <p:spTree>
+      <p:nvGrpSpPr>
+        <p:cNvPr id="1" name=""/>
+        <p:cNvGrpSpPr/>
+        <p:nvPr/>
+      </p:nvGrpSpPr>
+      <p:grpSpPr/>
+      <p:sp>
+        <p:nvSpPr>
+          <p:cNvPr id="2" name="Shape 0"/>
+          <p:cNvSpPr/>
+          <p:nvPr/>
+        </p:nvSpPr>
+        <p:spPr>
+          <a:xfrm>
+            <a:off x="548640" y="566928"/>
+            <a:ext cx="146304" cy="457200"/>
+          </a:xfrm>
+          <a:prstGeom prst="rect">
+            <a:avLst/>
+          </a:prstGeom>
+          <a:solidFill>
+            <a:srgbClr val="0E9594"/>
+          </a:solidFill>
+          <a:ln/>
+        </p:spPr>
+        <p:txBody>
+          <a:bodyPr/>
+          <a:p/>
+        </p:txBody>
+      </p:sp>
+      <p:sp>
+        <p:nvSpPr>
+          <p:cNvPr id="3" name="TextBox 2"/>
+          <p:cNvSpPr txBox="1"/>
+          <p:nvPr/>
+        </p:nvSpPr>
+        <p:spPr>
+          <a:xfrm>
+            <a:off x="822960" y="310896"/>
+            <a:ext cx="10515600" cy="292608"/>
+          </a:xfrm>
+          <a:prstGeom prst="rect">
+            <a:avLst/>
+          </a:prstGeom>
+          <a:noFill/>
+        </p:spPr>
+        <p:txBody>
+          <a:bodyPr wrap="square">
+            <a:spAutoFit/>
+          </a:bodyPr>
+          <a:lstStyle/>
+          <a:p>
+            <a:r>
+              <a:rPr b="1" sz="1200">
+                <a:solidFill>
+                  <a:srgbClr val="0E9594"/>
+                </a:solidFill>
+              </a:rPr>
+              <a:t>RESULTS · AUC VS FAKE RECALL</a:t>
+            </a:r>
+          </a:p>
+        </p:txBody>
+      </p:sp>
+      <p:sp>
+        <p:nvSpPr>
+          <p:cNvPr id="4" name="TextBox 3"/>
+          <p:cNvSpPr txBox="1"/>
+          <p:nvPr/>
+        </p:nvSpPr>
+        <p:spPr>
+          <a:xfrm>
+            <a:off x="822960" y="566928"/>
+            <a:ext cx="10789920" cy="640080"/>
+          </a:xfrm>
+          <a:prstGeom prst="rect">
+            <a:avLst/>
+          </a:prstGeom>
+          <a:noFill/>
+        </p:spPr>
+        <p:txBody>
+          <a:bodyPr wrap="square">
+            <a:spAutoFit/>
+          </a:bodyPr>
+          <a:lstStyle/>
+          <a:p>
+            <a:r>
+              <a:rPr b="1" sz="2800">
+                <a:solidFill>
+                  <a:srgbClr val="22303A"/>
+                </a:solidFill>
+              </a:rPr>
+              <a:t>Ranking quality vs calibration -- and where each model errors fall</a:t>
+            </a:r>
+          </a:p>
+        </p:txBody>
+      </p:sp>
+      <p:pic>
+        <p:nvPicPr>
+          <p:cNvPr id="5" name="Picture 4" descr="fig_auc_recall_error.png"/>
+          <p:cNvPicPr>
+            <a:picLocks noChangeAspect="1"/>
+          </p:cNvPicPr>
+          <p:nvPr/>
+        </p:nvPicPr>
+        <p:blipFill>
+          <a:blip r:embed="rId2"/>
+          <a:stretch>
+            <a:fillRect/>
+          </a:stretch>
+        </p:blipFill>
+        <p:spPr>
+          <a:xfrm>
+            <a:off x="548640" y="1500000"/>
+            <a:ext cx="11094720" cy="4572000"/>
+          </a:xfrm>
+          <a:prstGeom prst="rect">
+            <a:avLst/>
+          </a:prstGeom>
+        </p:spPr>
+      </p:pic>
+      <p:sp>
+        <p:nvSpPr>
+          <p:cNvPr id="6" name="TextBox 5"/>
+          <p:cNvSpPr txBox="1"/>
+          <p:nvPr/>
+        </p:nvSpPr>
+        <p:spPr>
+          <a:xfrm>
+            <a:off x="822960" y="6100000"/>
+            <a:ext cx="10515600" cy="300000"/>
+          </a:xfrm>
+          <a:prstGeom prst="rect">
+            <a:avLst/>
+          </a:prstGeom>
+          <a:noFill/>
+        </p:spPr>
+        <p:txBody>
+          <a:bodyPr wrap="square">
+            <a:spAutoFit/>
+          </a:bodyPr>
+          <a:lstStyle/>
+          <a:p>
+            <a:r>
+              <a:rPr b="0" sz="1000">
+                <a:solidFill>
+                  <a:srgbClr val="5C6B73"/>
+                </a:solidFill>
+              </a:rPr>
+              <a:t>High AUC + low fake-recall at threshold 0.5 = calibration problem, not a modelling failure. Only CNN and WavLM probe sit in the target zone (top-right).</a:t>
+            </a:r>
+          </a:p>
+        </p:txBody>
+      </p:sp>
+      <p:sp>
+        <p:nvSpPr>
+          <p:cNvPr id="7" name="TextBox 6"/>
+          <p:cNvSpPr txBox="1"/>
+          <p:nvPr/>
+        </p:nvSpPr>
+        <p:spPr>
+          <a:xfrm>
+            <a:off x="548640" y="6437376"/>
+            <a:ext cx="7315200" cy="274320"/>
+          </a:xfrm>
+          <a:prstGeom prst="rect">
+            <a:avLst/>
+          </a:prstGeom>
+          <a:noFill/>
+        </p:spPr>
+        <p:txBody>
+          <a:bodyPr wrap="square">
+            <a:spAutoFit/>
+          </a:bodyPr>
+          <a:lstStyle/>
+          <a:p>
+            <a:r>
+              <a:rPr b="0" sz="900">
+                <a:solidFill>
+                  <a:srgbClr val="6B7B85"/>
+                </a:solidFill>
+              </a:rPr>
+              <a:t>Audio Deepfake Detection — DL project</a:t>
+            </a:r>
+          </a:p>
+        </p:txBody>
+      </p:sp>
+      <p:sp>
+        <p:nvSpPr>
+          <p:cNvPr id="8" name="TextBox 7"/>
+          <p:cNvSpPr txBox="1"/>
+          <p:nvPr/>
+        </p:nvSpPr>
+        <p:spPr>
+          <a:xfrm>
+            <a:off x="11430000" y="6437376"/>
+            <a:ext cx="548640" cy="274320"/>
+          </a:xfrm>
+          <a:prstGeom prst="rect">
+            <a:avLst/>
+          </a:prstGeom>
+          <a:noFill/>
+        </p:spPr>
+        <p:txBody>
+          <a:bodyPr wrap="square">
+            <a:spAutoFit/>
+          </a:bodyPr>
+          <a:lstStyle/>
+          <a:p>
+            <a:r>
+              <a:rPr b="0" sz="900">
+                <a:solidFill>
+                  <a:srgbClr val="6B7B85"/>
+                </a:solidFill>
+              </a:rPr>
+              <a:t>12</a:t>
+            </a:r>
           </a:p>
         </p:txBody>
       </p:sp>
@@ -5115,6 +5530,10 @@
           </a:solidFill>
           <a:ln/>
         </p:spPr>
+        <p:txBody>
+          <a:bodyPr/>
+          <a:p/>
+        </p:txBody>
       </p:sp>
       <p:sp>
         <p:nvSpPr>
@@ -5323,6 +5742,10 @@
             <a:prstDash val="solid"/>
           </a:ln>
         </p:spPr>
+        <p:txBody>
+          <a:bodyPr/>
+          <a:p/>
+        </p:txBody>
       </p:sp>
       <p:sp>
         <p:nvSpPr>
@@ -5428,6 +5851,10 @@
             <a:prstDash val="solid"/>
           </a:ln>
         </p:spPr>
+        <p:txBody>
+          <a:bodyPr/>
+          <a:p/>
+        </p:txBody>
       </p:sp>
       <p:sp>
         <p:nvSpPr>
@@ -5636,6 +6063,10 @@
           </a:solidFill>
           <a:ln/>
         </p:spPr>
+        <p:txBody>
+          <a:bodyPr/>
+          <a:p/>
+        </p:txBody>
       </p:sp>
       <p:sp>
         <p:nvSpPr>
@@ -6514,7 +6945,7 @@
                           <a:ea typeface="Calibri" pitchFamily="34" charset="-122"/>
                           <a:cs typeface="Calibri" pitchFamily="34" charset="-120"/>
                         </a:rPr>
-                        <a:t>temporal modelling, with / without a CNN front-end</a:t>
+                        <a:t>temporal modelling, with / without a CNN block</a:t>
                       </a:r>
                       <a:endParaRPr lang="en-US" sz="1400" dirty="0">
                         <a:latin typeface="Calibri" charset="0"/>
@@ -6944,6 +7375,10 @@
           </a:solidFill>
           <a:ln/>
         </p:spPr>
+        <p:txBody>
+          <a:bodyPr/>
+          <a:p/>
+        </p:txBody>
       </p:sp>
       <p:sp>
         <p:nvSpPr>
@@ -7049,6 +7484,10 @@
             <a:prstDash val="solid"/>
           </a:ln>
         </p:spPr>
+        <p:txBody>
+          <a:bodyPr/>
+          <a:p/>
+        </p:txBody>
       </p:sp>
       <p:sp>
         <p:nvSpPr>
@@ -7069,6 +7508,10 @@
           </a:solidFill>
           <a:ln/>
         </p:spPr>
+        <p:txBody>
+          <a:bodyPr/>
+          <a:p/>
+        </p:txBody>
       </p:sp>
       <p:sp>
         <p:nvSpPr>
@@ -7174,6 +7617,10 @@
             <a:prstDash val="solid"/>
           </a:ln>
         </p:spPr>
+        <p:txBody>
+          <a:bodyPr/>
+          <a:p/>
+        </p:txBody>
       </p:sp>
       <p:sp>
         <p:nvSpPr>
@@ -7194,6 +7641,10 @@
           </a:solidFill>
           <a:ln/>
         </p:spPr>
+        <p:txBody>
+          <a:bodyPr/>
+          <a:p/>
+        </p:txBody>
       </p:sp>
       <p:sp>
         <p:nvSpPr>
@@ -7299,6 +7750,10 @@
             <a:prstDash val="solid"/>
           </a:ln>
         </p:spPr>
+        <p:txBody>
+          <a:bodyPr/>
+          <a:p/>
+        </p:txBody>
       </p:sp>
       <p:sp>
         <p:nvSpPr>
@@ -7319,6 +7774,10 @@
           </a:solidFill>
           <a:ln/>
         </p:spPr>
+        <p:txBody>
+          <a:bodyPr/>
+          <a:p/>
+        </p:txBody>
       </p:sp>
       <p:sp>
         <p:nvSpPr>
@@ -7424,6 +7883,10 @@
             <a:prstDash val="solid"/>
           </a:ln>
         </p:spPr>
+        <p:txBody>
+          <a:bodyPr/>
+          <a:p/>
+        </p:txBody>
       </p:sp>
       <p:sp>
         <p:nvSpPr>
@@ -7444,6 +7907,10 @@
           </a:solidFill>
           <a:ln/>
         </p:spPr>
+        <p:txBody>
+          <a:bodyPr/>
+          <a:p/>
+        </p:txBody>
       </p:sp>
       <p:sp>
         <p:nvSpPr>
@@ -7652,6 +8119,10 @@
           </a:solidFill>
           <a:ln/>
         </p:spPr>
+        <p:txBody>
+          <a:bodyPr/>
+          <a:p/>
+        </p:txBody>
       </p:sp>
       <p:sp>
         <p:nvSpPr>
@@ -7731,29 +8202,6 @@
           </a:p>
         </p:txBody>
       </p:sp>
-      <p:pic>
-        <p:nvPicPr>
-          <p:cNvPr id="5" name="Image 0" descr="/sessions/modest-trusting-fermi/mnt/outputs/slide_assets/mlp_eff.png">    </p:cNvPr>
-          <p:cNvPicPr>
-            <a:picLocks noChangeAspect="1"/>
-          </p:cNvPicPr>
-          <p:nvPr/>
-        </p:nvPicPr>
-        <p:blipFill>
-          <a:blip r:embed="rId1"/>
-          <a:srcRect l="0" r="0" t="0" b="0"/>
-          <a:stretch/>
-        </p:blipFill>
-        <p:spPr>
-          <a:xfrm>
-            <a:off x="731520" y="1691640"/>
-            <a:ext cx="7315200" cy="3931920"/>
-          </a:xfrm>
-          <a:prstGeom prst="rect">
-            <a:avLst/>
-          </a:prstGeom>
-        </p:spPr>
-      </p:pic>
       <p:sp>
         <p:nvSpPr>
           <p:cNvPr id="6" name="Text 3"/>
@@ -7897,6 +8345,167 @@
             </a:r>
             <a:endParaRPr lang="en-US" sz="1400" dirty="0"/>
           </a:p>
+          <a:p/>
+          <a:p>
+            <a:r>
+              <a:rPr lang="en-US" sz="800"/>
+              <a:t/>
+            </a:r>
+          </a:p>
+          <a:p>
+            <a:r>
+              <a:rPr lang="en-US" sz="950" b="1">
+                <a:solidFill>
+                  <a:srgbClr val="0E9594"/>
+                </a:solidFill>
+              </a:rPr>
+              <a:t>Baseline config</a:t>
+            </a:r>
+          </a:p>
+          <a:p>
+            <a:r>
+              <a:rPr lang="en-US" sz="900">
+                <a:solidFill>
+                  <a:srgbClr val="5C6B73"/>
+                </a:solidFill>
+              </a:rPr>
+              <a:t>Hidden layers: </a:t>
+            </a:r>
+            <a:r>
+              <a:rPr lang="en-US" sz="900">
+                <a:solidFill>
+                  <a:srgbClr val="22303A"/>
+                </a:solidFill>
+              </a:rPr>
+              <a:t>[256, 128, 64]</a:t>
+            </a:r>
+          </a:p>
+          <a:p>
+            <a:r>
+              <a:rPr lang="en-US" sz="900">
+                <a:solidFill>
+                  <a:srgbClr val="5C6B73"/>
+                </a:solidFill>
+              </a:rPr>
+              <a:t>Learning rate: </a:t>
+            </a:r>
+            <a:r>
+              <a:rPr lang="en-US" sz="900">
+                <a:solidFill>
+                  <a:srgbClr val="22303A"/>
+                </a:solidFill>
+              </a:rPr>
+              <a:t>5e-4</a:t>
+            </a:r>
+          </a:p>
+          <a:p>
+            <a:r>
+              <a:rPr lang="en-US" sz="900">
+                <a:solidFill>
+                  <a:srgbClr val="5C6B73"/>
+                </a:solidFill>
+              </a:rPr>
+              <a:t>Dropout / wd: </a:t>
+            </a:r>
+            <a:r>
+              <a:rPr lang="en-US" sz="900">
+                <a:solidFill>
+                  <a:srgbClr val="22303A"/>
+                </a:solidFill>
+              </a:rPr>
+              <a:t>0.5 / 1e-4</a:t>
+            </a:r>
+          </a:p>
+          <a:p>
+            <a:r>
+              <a:rPr lang="en-US" sz="900" b="1">
+                <a:solidFill>
+                  <a:srgbClr val="0E9594"/>
+                </a:solidFill>
+              </a:rPr>
+              <a:t>AUC 0.769  |  fake-recall 12%</a:t>
+            </a:r>
+          </a:p>
+          <a:p>
+            <a:r>
+              <a:rPr lang="en-US" sz="800"/>
+              <a:t/>
+            </a:r>
+          </a:p>
+          <a:p>
+            <a:r>
+              <a:rPr lang="en-US" sz="950" b="1">
+                <a:solidFill>
+                  <a:srgbClr val="C9971B"/>
+                </a:solidFill>
+              </a:rPr>
+              <a:t>Best config</a:t>
+            </a:r>
+          </a:p>
+          <a:p>
+            <a:r>
+              <a:rPr lang="en-US" sz="900">
+                <a:solidFill>
+                  <a:srgbClr val="5C6B73"/>
+                </a:solidFill>
+              </a:rPr>
+              <a:t>Hidden layers: </a:t>
+            </a:r>
+            <a:r>
+              <a:rPr lang="en-US" sz="900">
+                <a:solidFill>
+                  <a:srgbClr val="22303A"/>
+                </a:solidFill>
+              </a:rPr>
+              <a:t>[256, 128, 64]</a:t>
+            </a:r>
+          </a:p>
+          <a:p>
+            <a:r>
+              <a:rPr lang="en-US" sz="900">
+                <a:solidFill>
+                  <a:srgbClr val="5C6B73"/>
+                </a:solidFill>
+              </a:rPr>
+              <a:t>Learning rate: </a:t>
+            </a:r>
+            <a:r>
+              <a:rPr lang="en-US" sz="900">
+                <a:solidFill>
+                  <a:srgbClr val="22303A"/>
+                </a:solidFill>
+              </a:rPr>
+              <a:t>1e-3  ← only change</a:t>
+            </a:r>
+          </a:p>
+          <a:p>
+            <a:r>
+              <a:rPr lang="en-US" sz="900">
+                <a:solidFill>
+                  <a:srgbClr val="5C6B73"/>
+                </a:solidFill>
+              </a:rPr>
+              <a:t>Dropout / wd: </a:t>
+            </a:r>
+            <a:r>
+              <a:rPr lang="en-US" sz="900">
+                <a:solidFill>
+                  <a:srgbClr val="22303A"/>
+                </a:solidFill>
+              </a:rPr>
+              <a:t>0.5 / 1e-4</a:t>
+            </a:r>
+          </a:p>
+          <a:p>
+            <a:r>
+              <a:rPr lang="en-US" sz="900" b="1">
+                <a:solidFill>
+                  <a:srgbClr val="C9971B"/>
+                </a:solidFill>
+              </a:rPr>
+              <a:t>AUC 0.786  |  fake-recall 17%</a:t>
+            </a:r>
+          </a:p>
         </p:txBody>
       </p:sp>
       <p:sp>
@@ -7977,6 +8586,30 @@
           </a:p>
         </p:txBody>
       </p:sp>
+      <p:pic>
+        <p:nvPicPr>
+          <p:cNvPr id="10" name="Picture 9" descr="fig_mlp_hparam.png"/>
+          <p:cNvPicPr>
+            <a:picLocks noChangeAspect="1"/>
+          </p:cNvPicPr>
+          <p:nvPr/>
+        </p:nvPicPr>
+        <p:blipFill>
+          <a:blip r:embed="rId4"/>
+          <a:stretch>
+            <a:fillRect/>
+          </a:stretch>
+        </p:blipFill>
+        <p:spPr>
+          <a:xfrm>
+            <a:off x="731520" y="1691640"/>
+            <a:ext cx="7315200" cy="3931920"/>
+          </a:xfrm>
+          <a:prstGeom prst="rect">
+            <a:avLst/>
+          </a:prstGeom>
+        </p:spPr>
+      </p:pic>
     </p:spTree>
   </p:cSld>
   <p:clrMapOvr>
@@ -8028,6 +8661,10 @@
           </a:solidFill>
           <a:ln/>
         </p:spPr>
+        <p:txBody>
+          <a:bodyPr/>
+          <a:p/>
+        </p:txBody>
       </p:sp>
       <p:sp>
         <p:nvSpPr>
@@ -8107,29 +8744,6 @@
           </a:p>
         </p:txBody>
       </p:sp>
-      <p:pic>
-        <p:nvPicPr>
-          <p:cNvPr id="5" name="Image 0" descr="/sessions/modest-trusting-fermi/mnt/outputs/slide_assets/cnn_eff.png">    </p:cNvPr>
-          <p:cNvPicPr>
-            <a:picLocks noChangeAspect="1"/>
-          </p:cNvPicPr>
-          <p:nvPr/>
-        </p:nvPicPr>
-        <p:blipFill>
-          <a:blip r:embed="rId1"/>
-          <a:srcRect l="0" r="0" t="0" b="0"/>
-          <a:stretch/>
-        </p:blipFill>
-        <p:spPr>
-          <a:xfrm>
-            <a:off x="731520" y="1691640"/>
-            <a:ext cx="7315200" cy="3931920"/>
-          </a:xfrm>
-          <a:prstGeom prst="rect">
-            <a:avLst/>
-          </a:prstGeom>
-        </p:spPr>
-      </p:pic>
       <p:sp>
         <p:nvSpPr>
           <p:cNvPr id="6" name="Text 3"/>
@@ -8273,6 +8887,203 @@
             </a:r>
             <a:endParaRPr lang="en-US" sz="1400" dirty="0"/>
           </a:p>
+          <a:p/>
+          <a:p>
+            <a:r>
+              <a:rPr lang="en-US" sz="800"/>
+              <a:t/>
+            </a:r>
+          </a:p>
+          <a:p>
+            <a:r>
+              <a:rPr lang="en-US" sz="950" b="1">
+                <a:solidFill>
+                  <a:srgbClr val="0E9594"/>
+                </a:solidFill>
+              </a:rPr>
+              <a:t>Baseline config</a:t>
+            </a:r>
+          </a:p>
+          <a:p>
+            <a:r>
+              <a:rPr lang="en-US" sz="900">
+                <a:solidFill>
+                  <a:srgbClr val="5C6B73"/>
+                </a:solidFill>
+              </a:rPr>
+              <a:t>Conv depth / ch: </a:t>
+            </a:r>
+            <a:r>
+              <a:rPr lang="en-US" sz="900">
+                <a:solidFill>
+                  <a:srgbClr val="22303A"/>
+                </a:solidFill>
+              </a:rPr>
+              <a:t>3 blocks / 32 ch</a:t>
+            </a:r>
+          </a:p>
+          <a:p>
+            <a:r>
+              <a:rPr lang="en-US" sz="900">
+                <a:solidFill>
+                  <a:srgbClr val="5C6B73"/>
+                </a:solidFill>
+              </a:rPr>
+              <a:t>Learning rate: </a:t>
+            </a:r>
+            <a:r>
+              <a:rPr lang="en-US" sz="900">
+                <a:solidFill>
+                  <a:srgbClr val="22303A"/>
+                </a:solidFill>
+              </a:rPr>
+              <a:t>5e-4</a:t>
+            </a:r>
+          </a:p>
+          <a:p>
+            <a:r>
+              <a:rPr lang="en-US" sz="900">
+                <a:solidFill>
+                  <a:srgbClr val="5C6B73"/>
+                </a:solidFill>
+              </a:rPr>
+              <a:t>Dropout / wd: </a:t>
+            </a:r>
+            <a:r>
+              <a:rPr lang="en-US" sz="900">
+                <a:solidFill>
+                  <a:srgbClr val="22303A"/>
+                </a:solidFill>
+              </a:rPr>
+              <a:t>0.5 / 1e-4</a:t>
+            </a:r>
+          </a:p>
+          <a:p>
+            <a:r>
+              <a:rPr lang="en-US" sz="900">
+                <a:solidFill>
+                  <a:srgbClr val="5C6B73"/>
+                </a:solidFill>
+              </a:rPr>
+              <a:t>Note: </a:t>
+            </a:r>
+            <a:r>
+              <a:rPr lang="en-US" sz="900">
+                <a:solidFill>
+                  <a:srgbClr val="22303A"/>
+                </a:solidFill>
+              </a:rPr>
+              <a:t>dropout 0.3 beats 0.5 at this lr</a:t>
+            </a:r>
+          </a:p>
+          <a:p>
+            <a:r>
+              <a:rPr lang="en-US" sz="900" b="1">
+                <a:solidFill>
+                  <a:srgbClr val="0E9594"/>
+                </a:solidFill>
+              </a:rPr>
+              <a:t>AUC 0.681  |  fake-recall 46%</a:t>
+            </a:r>
+          </a:p>
+          <a:p>
+            <a:r>
+              <a:rPr lang="en-US" sz="800"/>
+              <a:t/>
+            </a:r>
+          </a:p>
+          <a:p>
+            <a:r>
+              <a:rPr lang="en-US" sz="950" b="1">
+                <a:solidFill>
+                  <a:srgbClr val="C9971B"/>
+                </a:solidFill>
+              </a:rPr>
+              <a:t>Best config</a:t>
+            </a:r>
+          </a:p>
+          <a:p>
+            <a:r>
+              <a:rPr lang="en-US" sz="900">
+                <a:solidFill>
+                  <a:srgbClr val="5C6B73"/>
+                </a:solidFill>
+              </a:rPr>
+              <a:t>Conv depth / ch: </a:t>
+            </a:r>
+            <a:r>
+              <a:rPr lang="en-US" sz="900">
+                <a:solidFill>
+                  <a:srgbClr val="22303A"/>
+                </a:solidFill>
+              </a:rPr>
+              <a:t>3 blocks / 32 ch</a:t>
+            </a:r>
+          </a:p>
+          <a:p>
+            <a:r>
+              <a:rPr lang="en-US" sz="900">
+                <a:solidFill>
+                  <a:srgbClr val="5C6B73"/>
+                </a:solidFill>
+              </a:rPr>
+              <a:t>Learning rate: </a:t>
+            </a:r>
+            <a:r>
+              <a:rPr lang="en-US" sz="900">
+                <a:solidFill>
+                  <a:srgbClr val="22303A"/>
+                </a:solidFill>
+              </a:rPr>
+              <a:t>1e-3  ← only change</a:t>
+            </a:r>
+          </a:p>
+          <a:p>
+            <a:r>
+              <a:rPr lang="en-US" sz="900">
+                <a:solidFill>
+                  <a:srgbClr val="5C6B73"/>
+                </a:solidFill>
+              </a:rPr>
+              <a:t>Dropout / wd: </a:t>
+            </a:r>
+            <a:r>
+              <a:rPr lang="en-US" sz="900">
+                <a:solidFill>
+                  <a:srgbClr val="22303A"/>
+                </a:solidFill>
+              </a:rPr>
+              <a:t>0.5 / 1e-4</a:t>
+            </a:r>
+          </a:p>
+          <a:p>
+            <a:r>
+              <a:rPr lang="en-US" sz="900">
+                <a:solidFill>
+                  <a:srgbClr val="5C6B73"/>
+                </a:solidFill>
+              </a:rPr>
+              <a:t>Note: </a:t>
+            </a:r>
+            <a:r>
+              <a:rPr lang="en-US" sz="900">
+                <a:solidFill>
+                  <a:srgbClr val="22303A"/>
+                </a:solidFill>
+              </a:rPr>
+              <a:t>lr×dropout interaction: lr 1e-3 needs do 0.5</a:t>
+            </a:r>
+          </a:p>
+          <a:p>
+            <a:r>
+              <a:rPr lang="en-US" sz="900" b="1">
+                <a:solidFill>
+                  <a:srgbClr val="C9971B"/>
+                </a:solidFill>
+              </a:rPr>
+              <a:t>AUC 0.870  |  fake-recall 72%</a:t>
+            </a:r>
+          </a:p>
         </p:txBody>
       </p:sp>
       <p:sp>
@@ -8353,6 +9164,30 @@
           </a:p>
         </p:txBody>
       </p:sp>
+      <p:pic>
+        <p:nvPicPr>
+          <p:cNvPr id="10" name="Picture 9" descr="fig_cnn_hparam.png"/>
+          <p:cNvPicPr>
+            <a:picLocks noChangeAspect="1"/>
+          </p:cNvPicPr>
+          <p:nvPr/>
+        </p:nvPicPr>
+        <p:blipFill>
+          <a:blip r:embed="rId4"/>
+          <a:stretch>
+            <a:fillRect/>
+          </a:stretch>
+        </p:blipFill>
+        <p:spPr>
+          <a:xfrm>
+            <a:off x="731520" y="1691640"/>
+            <a:ext cx="7315200" cy="3931920"/>
+          </a:xfrm>
+          <a:prstGeom prst="rect">
+            <a:avLst/>
+          </a:prstGeom>
+        </p:spPr>
+      </p:pic>
     </p:spTree>
   </p:cSld>
   <p:clrMapOvr>
@@ -8404,6 +9239,10 @@
           </a:solidFill>
           <a:ln/>
         </p:spPr>
+        <p:txBody>
+          <a:bodyPr/>
+          <a:p/>
+        </p:txBody>
       </p:sp>
       <p:sp>
         <p:nvSpPr>
@@ -8477,35 +9316,12 @@
                 <a:ea typeface="Trebuchet MS" pitchFamily="34" charset="-122"/>
                 <a:cs typeface="Trebuchet MS" pitchFamily="34" charset="-120"/>
               </a:rPr>
-              <a:t>Adding a CNN front-end to the recurrent path</a:t>
+              <a:t>Adding a CNN block to the recurrent path</a:t>
             </a:r>
             <a:endParaRPr lang="en-US" sz="2800" dirty="0"/>
           </a:p>
         </p:txBody>
       </p:sp>
-      <p:pic>
-        <p:nvPicPr>
-          <p:cNvPr id="5" name="Image 0" descr="/sessions/modest-trusting-fermi/mnt/outputs/slide_assets/crnn_eff.png">    </p:cNvPr>
-          <p:cNvPicPr>
-            <a:picLocks noChangeAspect="1"/>
-          </p:cNvPicPr>
-          <p:nvPr/>
-        </p:nvPicPr>
-        <p:blipFill>
-          <a:blip r:embed="rId1"/>
-          <a:srcRect l="0" r="0" t="0" b="0"/>
-          <a:stretch/>
-        </p:blipFill>
-        <p:spPr>
-          <a:xfrm>
-            <a:off x="731520" y="1691640"/>
-            <a:ext cx="7315200" cy="3931920"/>
-          </a:xfrm>
-          <a:prstGeom prst="rect">
-            <a:avLst/>
-          </a:prstGeom>
-        </p:spPr>
-      </p:pic>
       <p:sp>
         <p:nvSpPr>
           <p:cNvPr id="6" name="Text 3"/>
@@ -8582,7 +9398,7 @@
                 <a:ea typeface="Calibri" pitchFamily="34" charset="-122"/>
                 <a:cs typeface="Calibri" pitchFamily="34" charset="-120"/>
               </a:rPr>
-              <a:t>CRNN ≈ CNN (AUC ≈ 0.86): the conv front-end does the heavy lifting.</a:t>
+              <a:t>CRNN ≈ CNN (AUC ≈ 0.86): the CNN block does the heavy lifting.</a:t>
             </a:r>
             <a:endParaRPr lang="en-US" sz="1400" dirty="0"/>
           </a:p>
@@ -8649,6 +9465,167 @@
             </a:r>
             <a:endParaRPr lang="en-US" sz="1400" dirty="0"/>
           </a:p>
+          <a:p/>
+          <a:p>
+            <a:r>
+              <a:rPr lang="en-US" sz="800"/>
+              <a:t/>
+            </a:r>
+          </a:p>
+          <a:p>
+            <a:r>
+              <a:rPr lang="en-US" sz="950" b="1">
+                <a:solidFill>
+                  <a:srgbClr val="0E9594"/>
+                </a:solidFill>
+              </a:rPr>
+              <a:t>Baseline config</a:t>
+            </a:r>
+          </a:p>
+          <a:p>
+            <a:r>
+              <a:rPr lang="en-US" sz="900">
+                <a:solidFill>
+                  <a:srgbClr val="5C6B73"/>
+                </a:solidFill>
+              </a:rPr>
+              <a:t>CNN depth / ch: </a:t>
+            </a:r>
+            <a:r>
+              <a:rPr lang="en-US" sz="900">
+                <a:solidFill>
+                  <a:srgbClr val="22303A"/>
+                </a:solidFill>
+              </a:rPr>
+              <a:t>3 blocks / 32 ch</a:t>
+            </a:r>
+          </a:p>
+          <a:p>
+            <a:r>
+              <a:rPr lang="en-US" sz="900">
+                <a:solidFill>
+                  <a:srgbClr val="5C6B73"/>
+                </a:solidFill>
+              </a:rPr>
+              <a:t>BiLSTM layers / h: </a:t>
+            </a:r>
+            <a:r>
+              <a:rPr lang="en-US" sz="900">
+                <a:solidFill>
+                  <a:srgbClr val="22303A"/>
+                </a:solidFill>
+              </a:rPr>
+              <a:t>2 / 128</a:t>
+            </a:r>
+          </a:p>
+          <a:p>
+            <a:r>
+              <a:rPr lang="en-US" sz="900">
+                <a:solidFill>
+                  <a:srgbClr val="5C6B73"/>
+                </a:solidFill>
+              </a:rPr>
+              <a:t>Learning rate: </a:t>
+            </a:r>
+            <a:r>
+              <a:rPr lang="en-US" sz="900">
+                <a:solidFill>
+                  <a:srgbClr val="22303A"/>
+                </a:solidFill>
+              </a:rPr>
+              <a:t>5e-4</a:t>
+            </a:r>
+          </a:p>
+          <a:p>
+            <a:r>
+              <a:rPr lang="en-US" sz="900">
+                <a:solidFill>
+                  <a:srgbClr val="5C6B73"/>
+                </a:solidFill>
+              </a:rPr>
+              <a:t>Dropout / wd: </a:t>
+            </a:r>
+            <a:r>
+              <a:rPr lang="en-US" sz="900">
+                <a:solidFill>
+                  <a:srgbClr val="22303A"/>
+                </a:solidFill>
+              </a:rPr>
+              <a:t>0.5 / 1e-4</a:t>
+            </a:r>
+          </a:p>
+          <a:p>
+            <a:r>
+              <a:rPr lang="en-US" sz="900" b="1">
+                <a:solidFill>
+                  <a:srgbClr val="0E9594"/>
+                </a:solidFill>
+              </a:rPr>
+              <a:t>AUC 0.860  |  fake-recall 54%</a:t>
+            </a:r>
+          </a:p>
+          <a:p>
+            <a:r>
+              <a:rPr lang="en-US" sz="800"/>
+              <a:t/>
+            </a:r>
+          </a:p>
+          <a:p>
+            <a:r>
+              <a:rPr lang="en-US" sz="950" b="1">
+                <a:solidFill>
+                  <a:srgbClr val="C9971B"/>
+                </a:solidFill>
+              </a:rPr>
+              <a:t>Best config  =  Baseline</a:t>
+            </a:r>
+          </a:p>
+          <a:p>
+            <a:r>
+              <a:rPr lang="en-US" sz="900">
+                <a:solidFill>
+                  <a:srgbClr val="5C6B73"/>
+                </a:solidFill>
+              </a:rPr>
+              <a:t>Note: </a:t>
+            </a:r>
+            <a:r>
+              <a:rPr lang="en-US" sz="900">
+                <a:solidFill>
+                  <a:srgbClr val="22303A"/>
+                </a:solidFill>
+              </a:rPr>
+              <a:t>No variation improved on baseline</a:t>
+            </a:r>
+          </a:p>
+          <a:p>
+            <a:r>
+              <a:rPr lang="en-US" sz="900">
+                <a:solidFill>
+                  <a:srgbClr val="5C6B73"/>
+                </a:solidFill>
+              </a:rPr>
+              <a:t>Note: </a:t>
+            </a:r>
+            <a:r>
+              <a:rPr lang="en-US" sz="900">
+                <a:solidFill>
+                  <a:srgbClr val="22303A"/>
+                </a:solidFill>
+              </a:rPr>
+              <a:t>Baseline is already the global optimum</a:t>
+            </a:r>
+          </a:p>
+          <a:p>
+            <a:r>
+              <a:rPr lang="en-US" sz="900" b="1">
+                <a:solidFill>
+                  <a:srgbClr val="C9971B"/>
+                </a:solidFill>
+              </a:rPr>
+              <a:t>AUC 0.860  |  fake-recall 54%</a:t>
+            </a:r>
+          </a:p>
         </p:txBody>
       </p:sp>
       <p:sp>
@@ -8729,6 +9706,30 @@
           </a:p>
         </p:txBody>
       </p:sp>
+      <p:pic>
+        <p:nvPicPr>
+          <p:cNvPr id="10" name="Picture 9" descr="fig_crnn_hparam.png"/>
+          <p:cNvPicPr>
+            <a:picLocks noChangeAspect="1"/>
+          </p:cNvPicPr>
+          <p:nvPr/>
+        </p:nvPicPr>
+        <p:blipFill>
+          <a:blip r:embed="rId4"/>
+          <a:stretch>
+            <a:fillRect/>
+          </a:stretch>
+        </p:blipFill>
+        <p:spPr>
+          <a:xfrm>
+            <a:off x="731520" y="1691640"/>
+            <a:ext cx="7315200" cy="3931920"/>
+          </a:xfrm>
+          <a:prstGeom prst="rect">
+            <a:avLst/>
+          </a:prstGeom>
+        </p:spPr>
+      </p:pic>
     </p:spTree>
   </p:cSld>
   <p:clrMapOvr>
@@ -8780,6 +9781,10 @@
           </a:solidFill>
           <a:ln/>
         </p:spPr>
+        <p:txBody>
+          <a:bodyPr/>
+          <a:p/>
+        </p:txBody>
       </p:sp>
       <p:sp>
         <p:nvSpPr>
@@ -8859,29 +9864,6 @@
           </a:p>
         </p:txBody>
       </p:sp>
-      <p:pic>
-        <p:nvPicPr>
-          <p:cNvPr id="5" name="Image 0" descr="/sessions/modest-trusting-fermi/mnt/outputs/slide_assets/rnn_eff.png">    </p:cNvPr>
-          <p:cNvPicPr>
-            <a:picLocks noChangeAspect="1"/>
-          </p:cNvPicPr>
-          <p:nvPr/>
-        </p:nvPicPr>
-        <p:blipFill>
-          <a:blip r:embed="rId1"/>
-          <a:srcRect l="0" r="0" t="0" b="0"/>
-          <a:stretch/>
-        </p:blipFill>
-        <p:spPr>
-          <a:xfrm>
-            <a:off x="731520" y="1691640"/>
-            <a:ext cx="7315200" cy="3931920"/>
-          </a:xfrm>
-          <a:prstGeom prst="rect">
-            <a:avLst/>
-          </a:prstGeom>
-        </p:spPr>
-      </p:pic>
       <p:sp>
         <p:nvSpPr>
           <p:cNvPr id="6" name="Text 3"/>
@@ -9004,6 +9986,167 @@
             </a:r>
             <a:endParaRPr lang="en-US" sz="1400" dirty="0"/>
           </a:p>
+          <a:p/>
+          <a:p>
+            <a:r>
+              <a:rPr lang="en-US" sz="800"/>
+              <a:t/>
+            </a:r>
+          </a:p>
+          <a:p>
+            <a:r>
+              <a:rPr lang="en-US" sz="950" b="1">
+                <a:solidFill>
+                  <a:srgbClr val="0E9594"/>
+                </a:solidFill>
+              </a:rPr>
+              <a:t>Baseline config</a:t>
+            </a:r>
+          </a:p>
+          <a:p>
+            <a:r>
+              <a:rPr lang="en-US" sz="900">
+                <a:solidFill>
+                  <a:srgbClr val="5C6B73"/>
+                </a:solidFill>
+              </a:rPr>
+              <a:t>BiLSTM layers / h: </a:t>
+            </a:r>
+            <a:r>
+              <a:rPr lang="en-US" sz="900">
+                <a:solidFill>
+                  <a:srgbClr val="22303A"/>
+                </a:solidFill>
+              </a:rPr>
+              <a:t>2 / 128</a:t>
+            </a:r>
+          </a:p>
+          <a:p>
+            <a:r>
+              <a:rPr lang="en-US" sz="900">
+                <a:solidFill>
+                  <a:srgbClr val="5C6B73"/>
+                </a:solidFill>
+              </a:rPr>
+              <a:t>Learning rate: </a:t>
+            </a:r>
+            <a:r>
+              <a:rPr lang="en-US" sz="900">
+                <a:solidFill>
+                  <a:srgbClr val="22303A"/>
+                </a:solidFill>
+              </a:rPr>
+              <a:t>5e-4</a:t>
+            </a:r>
+          </a:p>
+          <a:p>
+            <a:r>
+              <a:rPr lang="en-US" sz="900">
+                <a:solidFill>
+                  <a:srgbClr val="5C6B73"/>
+                </a:solidFill>
+              </a:rPr>
+              <a:t>Dropout / wd: </a:t>
+            </a:r>
+            <a:r>
+              <a:rPr lang="en-US" sz="900">
+                <a:solidFill>
+                  <a:srgbClr val="22303A"/>
+                </a:solidFill>
+              </a:rPr>
+              <a:t>0.5 / 1e-4</a:t>
+            </a:r>
+          </a:p>
+          <a:p>
+            <a:r>
+              <a:rPr lang="en-US" sz="900" b="1">
+                <a:solidFill>
+                  <a:srgbClr val="0E9594"/>
+                </a:solidFill>
+              </a:rPr>
+              <a:t>AUC 0.592  |  fake-recall 12%</a:t>
+            </a:r>
+          </a:p>
+          <a:p>
+            <a:r>
+              <a:rPr lang="en-US" sz="800"/>
+              <a:t/>
+            </a:r>
+          </a:p>
+          <a:p>
+            <a:r>
+              <a:rPr lang="en-US" sz="950" b="1">
+                <a:solidFill>
+                  <a:srgbClr val="C9971B"/>
+                </a:solidFill>
+              </a:rPr>
+              <a:t>Best config</a:t>
+            </a:r>
+          </a:p>
+          <a:p>
+            <a:r>
+              <a:rPr lang="en-US" sz="900">
+                <a:solidFill>
+                  <a:srgbClr val="5C6B73"/>
+                </a:solidFill>
+              </a:rPr>
+              <a:t>BiLSTM layers / h: </a:t>
+            </a:r>
+            <a:r>
+              <a:rPr lang="en-US" sz="900">
+                <a:solidFill>
+                  <a:srgbClr val="22303A"/>
+                </a:solidFill>
+              </a:rPr>
+              <a:t>1 / 128  ← fewer layers</a:t>
+            </a:r>
+          </a:p>
+          <a:p>
+            <a:r>
+              <a:rPr lang="en-US" sz="900">
+                <a:solidFill>
+                  <a:srgbClr val="5C6B73"/>
+                </a:solidFill>
+              </a:rPr>
+              <a:t>Learning rate: </a:t>
+            </a:r>
+            <a:r>
+              <a:rPr lang="en-US" sz="900">
+                <a:solidFill>
+                  <a:srgbClr val="22303A"/>
+                </a:solidFill>
+              </a:rPr>
+              <a:t>5e-4</a:t>
+            </a:r>
+          </a:p>
+          <a:p>
+            <a:r>
+              <a:rPr lang="en-US" sz="900">
+                <a:solidFill>
+                  <a:srgbClr val="5C6B73"/>
+                </a:solidFill>
+              </a:rPr>
+              <a:t>Dropout / wd: </a:t>
+            </a:r>
+            <a:r>
+              <a:rPr lang="en-US" sz="900">
+                <a:solidFill>
+                  <a:srgbClr val="22303A"/>
+                </a:solidFill>
+              </a:rPr>
+              <a:t>0.5 / 1e-4</a:t>
+            </a:r>
+          </a:p>
+          <a:p>
+            <a:r>
+              <a:rPr lang="en-US" sz="900" b="1">
+                <a:solidFill>
+                  <a:srgbClr val="C9971B"/>
+                </a:solidFill>
+              </a:rPr>
+              <a:t>AUC 0.660  |  fake-recall 17%</a:t>
+            </a:r>
+          </a:p>
         </p:txBody>
       </p:sp>
       <p:sp>
@@ -9084,6 +10227,30 @@
           </a:p>
         </p:txBody>
       </p:sp>
+      <p:pic>
+        <p:nvPicPr>
+          <p:cNvPr id="10" name="Picture 9" descr="fig_rnn_hparam.png"/>
+          <p:cNvPicPr>
+            <a:picLocks noChangeAspect="1"/>
+          </p:cNvPicPr>
+          <p:nvPr/>
+        </p:nvPicPr>
+        <p:blipFill>
+          <a:blip r:embed="rId4"/>
+          <a:stretch>
+            <a:fillRect/>
+          </a:stretch>
+        </p:blipFill>
+        <p:spPr>
+          <a:xfrm>
+            <a:off x="731520" y="1691640"/>
+            <a:ext cx="7315200" cy="3931920"/>
+          </a:xfrm>
+          <a:prstGeom prst="rect">
+            <a:avLst/>
+          </a:prstGeom>
+        </p:spPr>
+      </p:pic>
     </p:spTree>
   </p:cSld>
   <p:clrMapOvr>
@@ -9135,6 +10302,10 @@
           </a:solidFill>
           <a:ln/>
         </p:spPr>
+        <p:txBody>
+          <a:bodyPr/>
+          <a:p/>
+        </p:txBody>
       </p:sp>
       <p:sp>
         <p:nvSpPr>
@@ -9214,29 +10385,6 @@
           </a:p>
         </p:txBody>
       </p:sp>
-      <p:pic>
-        <p:nvPicPr>
-          <p:cNvPr id="5" name="Image 0" descr="/sessions/modest-trusting-fermi/mnt/outputs/slide_assets/wavlm_layers.png">    </p:cNvPr>
-          <p:cNvPicPr>
-            <a:picLocks noChangeAspect="1"/>
-          </p:cNvPicPr>
-          <p:nvPr/>
-        </p:nvPicPr>
-        <p:blipFill>
-          <a:blip r:embed="rId1"/>
-          <a:srcRect l="0" r="0" t="0" b="0"/>
-          <a:stretch/>
-        </p:blipFill>
-        <p:spPr>
-          <a:xfrm>
-            <a:off x="731520" y="1828800"/>
-            <a:ext cx="6949440" cy="3474720"/>
-          </a:xfrm>
-          <a:prstGeom prst="rect">
-            <a:avLst/>
-          </a:prstGeom>
-        </p:spPr>
-      </p:pic>
       <p:sp>
         <p:nvSpPr>
           <p:cNvPr id="6" name="Text 3"/>
@@ -9341,6 +10489,167 @@
             </a:r>
             <a:endParaRPr lang="en-US" sz="1400" dirty="0"/>
           </a:p>
+          <a:p/>
+          <a:p>
+            <a:r>
+              <a:rPr lang="en-US" sz="800"/>
+              <a:t/>
+            </a:r>
+          </a:p>
+          <a:p>
+            <a:r>
+              <a:rPr lang="en-US" sz="950" b="1">
+                <a:solidFill>
+                  <a:srgbClr val="0E9594"/>
+                </a:solidFill>
+              </a:rPr>
+              <a:t>Frozen probe config</a:t>
+            </a:r>
+          </a:p>
+          <a:p>
+            <a:r>
+              <a:rPr lang="en-US" sz="900">
+                <a:solidFill>
+                  <a:srgbClr val="5C6B73"/>
+                </a:solidFill>
+              </a:rPr>
+              <a:t>Aggregation: </a:t>
+            </a:r>
+            <a:r>
+              <a:rPr lang="en-US" sz="900">
+                <a:solidFill>
+                  <a:srgbClr val="22303A"/>
+                </a:solidFill>
+              </a:rPr>
+              <a:t>Softmax-weighted sum, 12 layers</a:t>
+            </a:r>
+          </a:p>
+          <a:p>
+            <a:r>
+              <a:rPr lang="en-US" sz="900">
+                <a:solidFill>
+                  <a:srgbClr val="5C6B73"/>
+                </a:solidFill>
+              </a:rPr>
+              <a:t>Dominant layer: </a:t>
+            </a:r>
+            <a:r>
+              <a:rPr lang="en-US" sz="900">
+                <a:solidFill>
+                  <a:srgbClr val="22303A"/>
+                </a:solidFill>
+              </a:rPr>
+              <a:t>Layer 3 of 12  (~81% weight)</a:t>
+            </a:r>
+          </a:p>
+          <a:p>
+            <a:r>
+              <a:rPr lang="en-US" sz="900">
+                <a:solidFill>
+                  <a:srgbClr val="5C6B73"/>
+                </a:solidFill>
+              </a:rPr>
+              <a:t>Trainable params: </a:t>
+            </a:r>
+            <a:r>
+              <a:rPr lang="en-US" sz="900">
+                <a:solidFill>
+                  <a:srgbClr val="22303A"/>
+                </a:solidFill>
+              </a:rPr>
+              <a:t>~5K  (head only)</a:t>
+            </a:r>
+          </a:p>
+          <a:p>
+            <a:r>
+              <a:rPr lang="en-US" sz="900" b="1">
+                <a:solidFill>
+                  <a:srgbClr val="0E9594"/>
+                </a:solidFill>
+              </a:rPr>
+              <a:t>AUC 0.918  |  fake-recall 57%</a:t>
+            </a:r>
+          </a:p>
+          <a:p>
+            <a:r>
+              <a:rPr lang="en-US" sz="800"/>
+              <a:t/>
+            </a:r>
+          </a:p>
+          <a:p>
+            <a:r>
+              <a:rPr lang="en-US" sz="950" b="1">
+                <a:solidFill>
+                  <a:srgbClr val="C9971B"/>
+                </a:solidFill>
+              </a:rPr>
+              <a:t>Fine-tune best config</a:t>
+            </a:r>
+          </a:p>
+          <a:p>
+            <a:r>
+              <a:rPr lang="en-US" sz="900">
+                <a:solidFill>
+                  <a:srgbClr val="5C6B73"/>
+                </a:solidFill>
+              </a:rPr>
+              <a:t>Unfrozen layers: </a:t>
+            </a:r>
+            <a:r>
+              <a:rPr lang="en-US" sz="900">
+                <a:solidFill>
+                  <a:srgbClr val="22303A"/>
+                </a:solidFill>
+              </a:rPr>
+              <a:t>Top 2 transformer blocks</a:t>
+            </a:r>
+          </a:p>
+          <a:p>
+            <a:r>
+              <a:rPr lang="en-US" sz="900">
+                <a:solidFill>
+                  <a:srgbClr val="5C6B73"/>
+                </a:solidFill>
+              </a:rPr>
+              <a:t>lr backbone / head: </a:t>
+            </a:r>
+            <a:r>
+              <a:rPr lang="en-US" sz="900">
+                <a:solidFill>
+                  <a:srgbClr val="22303A"/>
+                </a:solidFill>
+              </a:rPr>
+              <a:t>1e-5 / 1e-3</a:t>
+            </a:r>
+          </a:p>
+          <a:p>
+            <a:r>
+              <a:rPr lang="en-US" sz="900">
+                <a:solidFill>
+                  <a:srgbClr val="5C6B73"/>
+                </a:solidFill>
+              </a:rPr>
+              <a:t>Batch / wd: </a:t>
+            </a:r>
+            <a:r>
+              <a:rPr lang="en-US" sz="900">
+                <a:solidFill>
+                  <a:srgbClr val="22303A"/>
+                </a:solidFill>
+              </a:rPr>
+              <a:t>32 / 0.01</a:t>
+            </a:r>
+          </a:p>
+          <a:p>
+            <a:r>
+              <a:rPr lang="en-US" sz="900" b="1">
+                <a:solidFill>
+                  <a:srgbClr val="C9971B"/>
+                </a:solidFill>
+              </a:rPr>
+              <a:t>AUC 0.865  |  fake-recall 45%  (domain shift)</a:t>
+            </a:r>
+          </a:p>
         </p:txBody>
       </p:sp>
       <p:sp>
@@ -9421,6 +10730,30 @@
           </a:p>
         </p:txBody>
       </p:sp>
+      <p:pic>
+        <p:nvPicPr>
+          <p:cNvPr id="9" name="Picture 8" descr="fig_wavlm_layers.png"/>
+          <p:cNvPicPr>
+            <a:picLocks noChangeAspect="1"/>
+          </p:cNvPicPr>
+          <p:nvPr/>
+        </p:nvPicPr>
+        <p:blipFill>
+          <a:blip r:embed="rId4"/>
+          <a:stretch>
+            <a:fillRect/>
+          </a:stretch>
+        </p:blipFill>
+        <p:spPr>
+          <a:xfrm>
+            <a:off x="731520" y="1828800"/>
+            <a:ext cx="6949440" cy="3474720"/>
+          </a:xfrm>
+          <a:prstGeom prst="rect">
+            <a:avLst/>
+          </a:prstGeom>
+        </p:spPr>
+      </p:pic>
     </p:spTree>
   </p:cSld>
   <p:clrMapOvr>

</xml_diff>